<commit_message>
Final touches to intro
</commit_message>
<xml_diff>
--- a/21_September_Monday/01_Intro_and_General_Concepts/McStas_McXtrace_Common_Introduction.pptx
+++ b/21_September_Monday/01_Intro_and_General_Concepts/McStas_McXtrace_Common_Introduction.pptx
@@ -5,7 +5,7 @@
     <p:sldMasterId id="2147483648" r:id="rId1"/>
   </p:sldMasterIdLst>
   <p:notesMasterIdLst>
-    <p:notesMasterId r:id="rId19"/>
+    <p:notesMasterId r:id="rId20"/>
   </p:notesMasterIdLst>
   <p:sldIdLst>
     <p:sldId id="274" r:id="rId2"/>
@@ -22,9 +22,10 @@
     <p:sldId id="285" r:id="rId13"/>
     <p:sldId id="286" r:id="rId14"/>
     <p:sldId id="287" r:id="rId15"/>
-    <p:sldId id="288" r:id="rId16"/>
-    <p:sldId id="289" r:id="rId17"/>
-    <p:sldId id="290" r:id="rId18"/>
+    <p:sldId id="292" r:id="rId16"/>
+    <p:sldId id="288" r:id="rId17"/>
+    <p:sldId id="289" r:id="rId18"/>
+    <p:sldId id="290" r:id="rId19"/>
   </p:sldIdLst>
   <p:sldSz cx="12192000" cy="6858000"/>
   <p:notesSz cx="6858000" cy="12192000"/>
@@ -762,7 +763,13 @@
   <p:cSld>
     <p:spTree>
       <p:nvGrpSpPr>
-        <p:cNvPr id="1" name=""/>
+        <p:cNvPr id="1" name="">
+          <a:extLst>
+            <a:ext uri="{FF2B5EF4-FFF2-40B4-BE49-F238E27FC236}">
+              <a16:creationId xmlns:a16="http://schemas.microsoft.com/office/drawing/2014/main" id="{498883C4-2306-6723-E4CB-ACF94257C9FA}"/>
+            </a:ext>
+          </a:extLst>
+        </p:cNvPr>
         <p:cNvGrpSpPr/>
         <p:nvPr/>
       </p:nvGrpSpPr>
@@ -776,7 +783,13 @@
       </p:grpSpPr>
       <p:sp>
         <p:nvSpPr>
-          <p:cNvPr id="2" name="Slide Image Placeholder 1"/>
+          <p:cNvPr id="2" name="Slide Image Placeholder 1">
+            <a:extLst>
+              <a:ext uri="{FF2B5EF4-FFF2-40B4-BE49-F238E27FC236}">
+                <a16:creationId xmlns:a16="http://schemas.microsoft.com/office/drawing/2014/main" id="{CCFB070D-CEF3-DFDE-2D65-7210B15FFD42}"/>
+              </a:ext>
+            </a:extLst>
+          </p:cNvPr>
           <p:cNvSpPr>
             <a:spLocks noGrp="1" noRot="1" noChangeAspect="1"/>
           </p:cNvSpPr>
@@ -788,7 +801,13 @@
       </p:sp>
       <p:sp>
         <p:nvSpPr>
-          <p:cNvPr id="3" name="Notes Placeholder 2"/>
+          <p:cNvPr id="3" name="Notes Placeholder 2">
+            <a:extLst>
+              <a:ext uri="{FF2B5EF4-FFF2-40B4-BE49-F238E27FC236}">
+                <a16:creationId xmlns:a16="http://schemas.microsoft.com/office/drawing/2014/main" id="{E5B11C7F-DD3A-7099-469A-2F774329AF61}"/>
+              </a:ext>
+            </a:extLst>
+          </p:cNvPr>
           <p:cNvSpPr>
             <a:spLocks noGrp="1"/>
           </p:cNvSpPr>
@@ -807,7 +826,13 @@
       </p:sp>
       <p:sp>
         <p:nvSpPr>
-          <p:cNvPr id="4" name="Slide Number Placeholder 3"/>
+          <p:cNvPr id="4" name="Slide Number Placeholder 3">
+            <a:extLst>
+              <a:ext uri="{FF2B5EF4-FFF2-40B4-BE49-F238E27FC236}">
+                <a16:creationId xmlns:a16="http://schemas.microsoft.com/office/drawing/2014/main" id="{49C53E84-8009-385F-FAB9-E7E0CCE1E21E}"/>
+              </a:ext>
+            </a:extLst>
+          </p:cNvPr>
           <p:cNvSpPr>
             <a:spLocks noGrp="1"/>
           </p:cNvSpPr>
@@ -831,7 +856,7 @@
     </p:spTree>
     <p:extLst>
       <p:ext uri="{BB962C8B-B14F-4D97-AF65-F5344CB8AC3E}">
-        <p14:creationId xmlns:p14="http://schemas.microsoft.com/office/powerpoint/2010/main" val="1024086991"/>
+        <p14:creationId xmlns:p14="http://schemas.microsoft.com/office/powerpoint/2010/main" val="2803608950"/>
       </p:ext>
     </p:extLst>
   </p:cSld>
@@ -991,6 +1016,90 @@
             <a:fld id="{F7021451-1387-4CA6-816F-3879F97B5CBC}" type="slidenum">
               <a:rPr lang="en-US"/>
               <a:t>17</a:t>
+            </a:fld>
+            <a:endParaRPr lang="en-US"/>
+          </a:p>
+        </p:txBody>
+      </p:sp>
+    </p:spTree>
+    <p:extLst>
+      <p:ext uri="{BB962C8B-B14F-4D97-AF65-F5344CB8AC3E}">
+        <p14:creationId xmlns:p14="http://schemas.microsoft.com/office/powerpoint/2010/main" val="1024086991"/>
+      </p:ext>
+    </p:extLst>
+  </p:cSld>
+  <p:clrMapOvr>
+    <a:masterClrMapping/>
+  </p:clrMapOvr>
+</p:notes>
+</file>
+
+<file path=ppt/notesSlides/notesSlide18.xml><?xml version="1.0" encoding="utf-8"?>
+<p:notes xmlns:a="http://schemas.openxmlformats.org/drawingml/2006/main" xmlns:r="http://schemas.openxmlformats.org/officeDocument/2006/relationships" xmlns:p="http://schemas.openxmlformats.org/presentationml/2006/main">
+  <p:cSld>
+    <p:spTree>
+      <p:nvGrpSpPr>
+        <p:cNvPr id="1" name=""/>
+        <p:cNvGrpSpPr/>
+        <p:nvPr/>
+      </p:nvGrpSpPr>
+      <p:grpSpPr>
+        <a:xfrm>
+          <a:off x="0" y="0"/>
+          <a:ext cx="0" cy="0"/>
+          <a:chOff x="0" y="0"/>
+          <a:chExt cx="0" cy="0"/>
+        </a:xfrm>
+      </p:grpSpPr>
+      <p:sp>
+        <p:nvSpPr>
+          <p:cNvPr id="2" name="Slide Image Placeholder 1"/>
+          <p:cNvSpPr>
+            <a:spLocks noGrp="1" noRot="1" noChangeAspect="1"/>
+          </p:cNvSpPr>
+          <p:nvPr>
+            <p:ph type="sldImg"/>
+          </p:nvPr>
+        </p:nvSpPr>
+        <p:spPr/>
+      </p:sp>
+      <p:sp>
+        <p:nvSpPr>
+          <p:cNvPr id="3" name="Notes Placeholder 2"/>
+          <p:cNvSpPr>
+            <a:spLocks noGrp="1"/>
+          </p:cNvSpPr>
+          <p:nvPr>
+            <p:ph type="body" idx="1"/>
+          </p:nvPr>
+        </p:nvSpPr>
+        <p:spPr/>
+        <p:txBody>
+          <a:bodyPr/>
+          <a:lstStyle/>
+          <a:p>
+            <a:endParaRPr lang="en-US" dirty="0"/>
+          </a:p>
+        </p:txBody>
+      </p:sp>
+      <p:sp>
+        <p:nvSpPr>
+          <p:cNvPr id="4" name="Slide Number Placeholder 3"/>
+          <p:cNvSpPr>
+            <a:spLocks noGrp="1"/>
+          </p:cNvSpPr>
+          <p:nvPr>
+            <p:ph type="sldNum" sz="quarter" idx="10"/>
+          </p:nvPr>
+        </p:nvSpPr>
+        <p:spPr/>
+        <p:txBody>
+          <a:bodyPr/>
+          <a:lstStyle/>
+          <a:p>
+            <a:fld id="{F7021451-1387-4CA6-816F-3879F97B5CBC}" type="slidenum">
+              <a:rPr lang="en-US"/>
+              <a:t>18</a:t>
             </a:fld>
             <a:endParaRPr lang="en-US"/>
           </a:p>
@@ -2026,7 +2135,7 @@
         </p:nvSpPr>
         <p:spPr>
           <a:xfrm>
-            <a:off x="9418320" y="-1463040"/>
+            <a:off x="9392886" y="-1425959"/>
             <a:ext cx="4754880" cy="4754880"/>
           </a:xfrm>
           <a:prstGeom prst="ellipse">
@@ -2448,36 +2557,6 @@
           </a:p>
         </p:txBody>
       </p:sp>
-      <p:pic>
-        <p:nvPicPr>
-          <p:cNvPr id="14" name="Picture 13">
-            <a:extLst>
-              <a:ext uri="{FF2B5EF4-FFF2-40B4-BE49-F238E27FC236}">
-                <a16:creationId xmlns:a16="http://schemas.microsoft.com/office/drawing/2014/main" id="{86DBB71B-0EDB-27E8-F7F5-7BBCD5423B98}"/>
-              </a:ext>
-            </a:extLst>
-          </p:cNvPr>
-          <p:cNvPicPr>
-            <a:picLocks noChangeAspect="1"/>
-          </p:cNvPicPr>
-          <p:nvPr/>
-        </p:nvPicPr>
-        <p:blipFill>
-          <a:blip r:embed="rId3"/>
-          <a:stretch>
-            <a:fillRect/>
-          </a:stretch>
-        </p:blipFill>
-        <p:spPr>
-          <a:xfrm>
-            <a:off x="7759700" y="4019550"/>
-            <a:ext cx="3149600" cy="979381"/>
-          </a:xfrm>
-          <a:prstGeom prst="rect">
-            <a:avLst/>
-          </a:prstGeom>
-        </p:spPr>
-      </p:pic>
       <p:sp>
         <p:nvSpPr>
           <p:cNvPr id="15" name="SchoolCredit">
@@ -2542,7 +2621,7 @@
           <p:nvPr/>
         </p:nvPicPr>
         <p:blipFill>
-          <a:blip r:embed="rId4"/>
+          <a:blip r:embed="rId3"/>
           <a:srcRect l="11719" t="16994"/>
           <a:stretch>
             <a:fillRect/>
@@ -2573,7 +2652,7 @@
           <p:nvPr/>
         </p:nvPicPr>
         <p:blipFill>
-          <a:blip r:embed="rId5"/>
+          <a:blip r:embed="rId4"/>
           <a:stretch>
             <a:fillRect/>
           </a:stretch>
@@ -2588,6 +2667,171 @@
           </a:prstGeom>
         </p:spPr>
       </p:pic>
+      <p:grpSp>
+        <p:nvGrpSpPr>
+          <p:cNvPr id="17" name="Group 16">
+            <a:extLst>
+              <a:ext uri="{FF2B5EF4-FFF2-40B4-BE49-F238E27FC236}">
+                <a16:creationId xmlns:a16="http://schemas.microsoft.com/office/drawing/2014/main" id="{32714F71-B65E-01C7-3ED0-973B6634ADFC}"/>
+              </a:ext>
+            </a:extLst>
+          </p:cNvPr>
+          <p:cNvGrpSpPr>
+            <a:grpSpLocks noChangeAspect="1"/>
+          </p:cNvGrpSpPr>
+          <p:nvPr/>
+        </p:nvGrpSpPr>
+        <p:grpSpPr>
+          <a:xfrm>
+            <a:off x="7936130" y="3847669"/>
+            <a:ext cx="2796739" cy="1321661"/>
+            <a:chOff x="8424483" y="116876"/>
+            <a:chExt cx="1591152" cy="751934"/>
+          </a:xfrm>
+        </p:grpSpPr>
+        <p:grpSp>
+          <p:nvGrpSpPr>
+            <p:cNvPr id="19" name="Group 18">
+              <a:extLst>
+                <a:ext uri="{FF2B5EF4-FFF2-40B4-BE49-F238E27FC236}">
+                  <a16:creationId xmlns:a16="http://schemas.microsoft.com/office/drawing/2014/main" id="{08E4AC95-08A8-C47E-DEC4-F1FF0BDB7FC9}"/>
+                </a:ext>
+              </a:extLst>
+            </p:cNvPr>
+            <p:cNvGrpSpPr/>
+            <p:nvPr/>
+          </p:nvGrpSpPr>
+          <p:grpSpPr>
+            <a:xfrm>
+              <a:off x="9225045" y="116876"/>
+              <a:ext cx="790590" cy="715989"/>
+              <a:chOff x="9198715" y="165515"/>
+              <a:chExt cx="790590" cy="715989"/>
+            </a:xfrm>
+          </p:grpSpPr>
+          <p:pic>
+            <p:nvPicPr>
+              <p:cNvPr id="21" name="Picture 20">
+                <a:extLst>
+                  <a:ext uri="{FF2B5EF4-FFF2-40B4-BE49-F238E27FC236}">
+                    <a16:creationId xmlns:a16="http://schemas.microsoft.com/office/drawing/2014/main" id="{1C4B1995-1F3A-2175-CEA0-2E1E9E7CC3EB}"/>
+                  </a:ext>
+                </a:extLst>
+              </p:cNvPr>
+              <p:cNvPicPr>
+                <a:picLocks noChangeAspect="1"/>
+              </p:cNvPicPr>
+              <p:nvPr/>
+            </p:nvPicPr>
+            <p:blipFill>
+              <a:blip r:embed="rId5"/>
+              <a:srcRect l="48140"/>
+              <a:stretch>
+                <a:fillRect/>
+              </a:stretch>
+            </p:blipFill>
+            <p:spPr>
+              <a:xfrm>
+                <a:off x="9226947" y="165515"/>
+                <a:ext cx="736600" cy="441669"/>
+              </a:xfrm>
+              <a:prstGeom prst="rect">
+                <a:avLst/>
+              </a:prstGeom>
+            </p:spPr>
+          </p:pic>
+          <p:pic>
+            <p:nvPicPr>
+              <p:cNvPr id="22" name="Picture 21" descr="Synchrotron SOLEIL">
+                <a:extLst>
+                  <a:ext uri="{FF2B5EF4-FFF2-40B4-BE49-F238E27FC236}">
+                    <a16:creationId xmlns:a16="http://schemas.microsoft.com/office/drawing/2014/main" id="{FCBF8479-1DC9-E6F0-00C2-53AC79BC6B20}"/>
+                  </a:ext>
+                </a:extLst>
+              </p:cNvPr>
+              <p:cNvPicPr>
+                <a:picLocks noChangeAspect="1"/>
+              </p:cNvPicPr>
+              <p:nvPr/>
+            </p:nvPicPr>
+            <p:blipFill>
+              <a:blip r:embed="rId6"/>
+              <a:stretch>
+                <a:fillRect/>
+              </a:stretch>
+            </p:blipFill>
+            <p:spPr>
+              <a:xfrm>
+                <a:off x="9198715" y="580162"/>
+                <a:ext cx="548117" cy="264791"/>
+              </a:xfrm>
+              <a:prstGeom prst="rect">
+                <a:avLst/>
+              </a:prstGeom>
+            </p:spPr>
+          </p:pic>
+          <p:pic>
+            <p:nvPicPr>
+              <p:cNvPr id="23" name="Picture 22" descr="DTU Physics">
+                <a:extLst>
+                  <a:ext uri="{FF2B5EF4-FFF2-40B4-BE49-F238E27FC236}">
+                    <a16:creationId xmlns:a16="http://schemas.microsoft.com/office/drawing/2014/main" id="{C2C27E3B-C709-799E-A3D6-231CFA4D2A55}"/>
+                  </a:ext>
+                </a:extLst>
+              </p:cNvPr>
+              <p:cNvPicPr>
+                <a:picLocks noChangeAspect="1"/>
+              </p:cNvPicPr>
+              <p:nvPr/>
+            </p:nvPicPr>
+            <p:blipFill>
+              <a:blip r:embed="rId7"/>
+              <a:stretch>
+                <a:fillRect/>
+              </a:stretch>
+            </p:blipFill>
+            <p:spPr>
+              <a:xfrm>
+                <a:off x="9787903" y="584997"/>
+                <a:ext cx="201402" cy="296507"/>
+              </a:xfrm>
+              <a:prstGeom prst="rect">
+                <a:avLst/>
+              </a:prstGeom>
+            </p:spPr>
+          </p:pic>
+        </p:grpSp>
+        <p:pic>
+          <p:nvPicPr>
+            <p:cNvPr id="20" name="Picture 19">
+              <a:extLst>
+                <a:ext uri="{FF2B5EF4-FFF2-40B4-BE49-F238E27FC236}">
+                  <a16:creationId xmlns:a16="http://schemas.microsoft.com/office/drawing/2014/main" id="{22A63A93-FE72-92A5-7E70-D0E5B0B65DB5}"/>
+                </a:ext>
+              </a:extLst>
+            </p:cNvPr>
+            <p:cNvPicPr>
+              <a:picLocks noChangeAspect="1"/>
+            </p:cNvPicPr>
+            <p:nvPr/>
+          </p:nvPicPr>
+          <p:blipFill>
+            <a:blip r:embed="rId8"/>
+            <a:stretch>
+              <a:fillRect/>
+            </a:stretch>
+          </p:blipFill>
+          <p:spPr>
+            <a:xfrm>
+              <a:off x="8424483" y="119510"/>
+              <a:ext cx="736600" cy="749300"/>
+            </a:xfrm>
+            <a:prstGeom prst="rect">
+              <a:avLst/>
+            </a:prstGeom>
+          </p:spPr>
+        </p:pic>
+      </p:grpSp>
     </p:spTree>
     <p:extLst>
       <p:ext uri="{BB962C8B-B14F-4D97-AF65-F5344CB8AC3E}">
@@ -3626,7 +3870,7 @@
           </a:ln>
           <a:extLst>
             <a:ext uri="{C572A759-6A51-4108-AA02-DFA0A04FC94B}">
-              <ma14:wrappingTextBoxFlag xmlns:ma14="http://schemas.microsoft.com/office/mac/drawingml/2011/main" xmlns:a14="http://schemas.microsoft.com/office/drawing/2010/main" xmlns:m="http://schemas.openxmlformats.org/officeDocument/2006/math" xmlns="" val="1"/>
+              <ma14:wrappingTextBoxFlag xmlns="" xmlns:m="http://schemas.openxmlformats.org/officeDocument/2006/math" xmlns:a14="http://schemas.microsoft.com/office/drawing/2010/main" xmlns:ma14="http://schemas.microsoft.com/office/mac/drawingml/2011/main" val="1"/>
             </a:ext>
           </a:extLst>
         </p:spPr>
@@ -3667,7 +3911,7 @@
           </a:ln>
           <a:extLst>
             <a:ext uri="{C572A759-6A51-4108-AA02-DFA0A04FC94B}">
-              <ma14:wrappingTextBoxFlag xmlns:ma14="http://schemas.microsoft.com/office/mac/drawingml/2011/main" xmlns:a14="http://schemas.microsoft.com/office/drawing/2010/main" xmlns:m="http://schemas.openxmlformats.org/officeDocument/2006/math" xmlns="" val="1"/>
+              <ma14:wrappingTextBoxFlag xmlns="" xmlns:m="http://schemas.openxmlformats.org/officeDocument/2006/math" xmlns:a14="http://schemas.microsoft.com/office/drawing/2010/main" xmlns:ma14="http://schemas.microsoft.com/office/mac/drawingml/2011/main" val="1"/>
             </a:ext>
           </a:extLst>
         </p:spPr>
@@ -3708,7 +3952,7 @@
           </a:ln>
           <a:extLst>
             <a:ext uri="{C572A759-6A51-4108-AA02-DFA0A04FC94B}">
-              <ma14:wrappingTextBoxFlag xmlns:ma14="http://schemas.microsoft.com/office/mac/drawingml/2011/main" xmlns:a14="http://schemas.microsoft.com/office/drawing/2010/main" xmlns:m="http://schemas.openxmlformats.org/officeDocument/2006/math" xmlns="" val="1"/>
+              <ma14:wrappingTextBoxFlag xmlns="" xmlns:m="http://schemas.openxmlformats.org/officeDocument/2006/math" xmlns:a14="http://schemas.microsoft.com/office/drawing/2010/main" xmlns:ma14="http://schemas.microsoft.com/office/mac/drawingml/2011/main" val="1"/>
             </a:ext>
           </a:extLst>
         </p:spPr>
@@ -6632,8 +6876,37 @@
                 <a:ea typeface="Calibri" pitchFamily="34" charset="-122"/>
                 <a:cs typeface="Calibri" pitchFamily="34" charset="-120"/>
               </a:rPr>
+              <a:t>DTU Space</a:t>
+            </a:r>
+          </a:p>
+          <a:p>
+            <a:pPr marL="177800" indent="-177800">
+              <a:spcAft>
+                <a:spcPts val="800"/>
+              </a:spcAft>
+              <a:buSzPct val="100000"/>
+              <a:buChar char="•"/>
+            </a:pPr>
+            <a:r>
+              <a:rPr lang="en-US" sz="1200" dirty="0">
+                <a:solidFill>
+                  <a:srgbClr val="20242B"/>
+                </a:solidFill>
+                <a:latin typeface="Calibri" pitchFamily="34" charset="0"/>
+                <a:ea typeface="Calibri" pitchFamily="34" charset="-122"/>
+                <a:cs typeface="Calibri" pitchFamily="34" charset="-120"/>
+              </a:rPr>
               <a:t>University of Copenhagen</a:t>
             </a:r>
+          </a:p>
+          <a:p>
+            <a:pPr marL="177800" indent="-177800">
+              <a:spcAft>
+                <a:spcPts val="800"/>
+              </a:spcAft>
+              <a:buSzPct val="100000"/>
+              <a:buChar char="•"/>
+            </a:pPr>
             <a:endParaRPr lang="en-US" sz="1200" dirty="0"/>
           </a:p>
         </p:txBody>
@@ -8071,6 +8344,1121 @@
 
 <file path=ppt/slides/slide15.xml><?xml version="1.0" encoding="utf-8"?>
 <p:sld xmlns:a="http://schemas.openxmlformats.org/drawingml/2006/main" xmlns:r="http://schemas.openxmlformats.org/officeDocument/2006/relationships" xmlns:p="http://schemas.openxmlformats.org/presentationml/2006/main">
+  <p:cSld>
+    <p:bg>
+      <p:bgPr>
+        <a:solidFill>
+          <a:srgbClr val="FFFFFF"/>
+        </a:solidFill>
+        <a:effectLst/>
+      </p:bgPr>
+    </p:bg>
+    <p:spTree>
+      <p:nvGrpSpPr>
+        <p:cNvPr id="1" name="">
+          <a:extLst>
+            <a:ext uri="{FF2B5EF4-FFF2-40B4-BE49-F238E27FC236}">
+              <a16:creationId xmlns:a16="http://schemas.microsoft.com/office/drawing/2014/main" id="{43A4785A-F4A1-3288-604F-E5E3E026EBAE}"/>
+            </a:ext>
+          </a:extLst>
+        </p:cNvPr>
+        <p:cNvGrpSpPr/>
+        <p:nvPr/>
+      </p:nvGrpSpPr>
+      <p:grpSpPr>
+        <a:xfrm>
+          <a:off x="0" y="0"/>
+          <a:ext cx="0" cy="0"/>
+          <a:chOff x="0" y="0"/>
+          <a:chExt cx="0" cy="0"/>
+        </a:xfrm>
+      </p:grpSpPr>
+      <p:sp>
+        <p:nvSpPr>
+          <p:cNvPr id="2" name="Text 0">
+            <a:extLst>
+              <a:ext uri="{FF2B5EF4-FFF2-40B4-BE49-F238E27FC236}">
+                <a16:creationId xmlns:a16="http://schemas.microsoft.com/office/drawing/2014/main" id="{DDE121A3-AC8B-5461-E1FE-9D0D3FA13244}"/>
+              </a:ext>
+            </a:extLst>
+          </p:cNvPr>
+          <p:cNvSpPr/>
+          <p:nvPr/>
+        </p:nvSpPr>
+        <p:spPr>
+          <a:xfrm>
+            <a:off x="548640" y="384048"/>
+            <a:ext cx="9144000" cy="292608"/>
+          </a:xfrm>
+          <a:prstGeom prst="rect">
+            <a:avLst/>
+          </a:prstGeom>
+          <a:noFill/>
+          <a:ln/>
+        </p:spPr>
+        <p:txBody>
+          <a:bodyPr wrap="square" rtlCol="0" anchor="ctr"/>
+          <a:lstStyle/>
+          <a:p>
+            <a:pPr marL="0" indent="0">
+              <a:buNone/>
+            </a:pPr>
+            <a:r>
+              <a:rPr lang="en-US" sz="1200" b="1" kern="0" spc="200" dirty="0">
+                <a:solidFill>
+                  <a:srgbClr val="1C7293"/>
+                </a:solidFill>
+                <a:latin typeface="Calibri" pitchFamily="34" charset="0"/>
+                <a:ea typeface="Calibri" pitchFamily="34" charset="-122"/>
+                <a:cs typeface="Calibri" pitchFamily="34" charset="-120"/>
+              </a:rPr>
+              <a:t>ECOSYSTEM</a:t>
+            </a:r>
+            <a:endParaRPr lang="en-US" sz="1200" dirty="0"/>
+          </a:p>
+        </p:txBody>
+      </p:sp>
+      <p:sp>
+        <p:nvSpPr>
+          <p:cNvPr id="3" name="Text 1">
+            <a:extLst>
+              <a:ext uri="{FF2B5EF4-FFF2-40B4-BE49-F238E27FC236}">
+                <a16:creationId xmlns:a16="http://schemas.microsoft.com/office/drawing/2014/main" id="{FB1363F1-30B5-D70E-4790-8F3A4C16162D}"/>
+              </a:ext>
+            </a:extLst>
+          </p:cNvPr>
+          <p:cNvSpPr/>
+          <p:nvPr/>
+        </p:nvSpPr>
+        <p:spPr>
+          <a:xfrm>
+            <a:off x="548640" y="658368"/>
+            <a:ext cx="11064240" cy="822960"/>
+          </a:xfrm>
+          <a:prstGeom prst="rect">
+            <a:avLst/>
+          </a:prstGeom>
+          <a:noFill/>
+          <a:ln/>
+        </p:spPr>
+        <p:txBody>
+          <a:bodyPr wrap="square" rtlCol="0" anchor="ctr"/>
+          <a:lstStyle/>
+          <a:p>
+            <a:pPr marL="0" indent="0" algn="l">
+              <a:buNone/>
+            </a:pPr>
+            <a:r>
+              <a:rPr lang="en-US" sz="3000" b="1" dirty="0">
+                <a:solidFill>
+                  <a:srgbClr val="20242B"/>
+                </a:solidFill>
+                <a:latin typeface="Cambria" pitchFamily="34" charset="0"/>
+                <a:ea typeface="Cambria" pitchFamily="34" charset="-122"/>
+                <a:cs typeface="Cambria" pitchFamily="34" charset="-120"/>
+              </a:rPr>
+              <a:t>A shared, interoperable ecosystem</a:t>
+            </a:r>
+            <a:endParaRPr lang="en-US" sz="3000" dirty="0"/>
+          </a:p>
+        </p:txBody>
+      </p:sp>
+      <p:sp>
+        <p:nvSpPr>
+          <p:cNvPr id="4" name="Shape 2">
+            <a:extLst>
+              <a:ext uri="{FF2B5EF4-FFF2-40B4-BE49-F238E27FC236}">
+                <a16:creationId xmlns:a16="http://schemas.microsoft.com/office/drawing/2014/main" id="{8995D224-65E6-B7E0-67A2-005F87E6916E}"/>
+              </a:ext>
+            </a:extLst>
+          </p:cNvPr>
+          <p:cNvSpPr/>
+          <p:nvPr/>
+        </p:nvSpPr>
+        <p:spPr>
+          <a:xfrm>
+            <a:off x="548640" y="1783080"/>
+            <a:ext cx="5394960" cy="1965960"/>
+          </a:xfrm>
+          <a:prstGeom prst="roundRect">
+            <a:avLst>
+              <a:gd name="adj" fmla="val 4186"/>
+            </a:avLst>
+          </a:prstGeom>
+          <a:solidFill>
+            <a:srgbClr val="F7F8FA"/>
+          </a:solidFill>
+          <a:ln/>
+        </p:spPr>
+        <p:txBody>
+          <a:bodyPr/>
+          <a:lstStyle/>
+          <a:p>
+            <a:endParaRPr lang="en-DK"/>
+          </a:p>
+        </p:txBody>
+      </p:sp>
+      <p:sp>
+        <p:nvSpPr>
+          <p:cNvPr id="5" name="Shape 3">
+            <a:extLst>
+              <a:ext uri="{FF2B5EF4-FFF2-40B4-BE49-F238E27FC236}">
+                <a16:creationId xmlns:a16="http://schemas.microsoft.com/office/drawing/2014/main" id="{185218B3-9A32-6392-2863-7DC785FF56B1}"/>
+              </a:ext>
+            </a:extLst>
+          </p:cNvPr>
+          <p:cNvSpPr/>
+          <p:nvPr/>
+        </p:nvSpPr>
+        <p:spPr>
+          <a:xfrm>
+            <a:off x="822960" y="2039112"/>
+            <a:ext cx="457200" cy="457200"/>
+          </a:xfrm>
+          <a:prstGeom prst="ellipse">
+            <a:avLst/>
+          </a:prstGeom>
+          <a:solidFill>
+            <a:srgbClr val="E3EEF2"/>
+          </a:solidFill>
+          <a:ln/>
+        </p:spPr>
+        <p:txBody>
+          <a:bodyPr/>
+          <a:lstStyle/>
+          <a:p>
+            <a:endParaRPr lang="en-DK"/>
+          </a:p>
+        </p:txBody>
+      </p:sp>
+      <p:sp>
+        <p:nvSpPr>
+          <p:cNvPr id="6" name="Text 4">
+            <a:extLst>
+              <a:ext uri="{FF2B5EF4-FFF2-40B4-BE49-F238E27FC236}">
+                <a16:creationId xmlns:a16="http://schemas.microsoft.com/office/drawing/2014/main" id="{EC760D90-A67E-9F2E-D54D-2DB53C19B105}"/>
+              </a:ext>
+            </a:extLst>
+          </p:cNvPr>
+          <p:cNvSpPr/>
+          <p:nvPr/>
+        </p:nvSpPr>
+        <p:spPr>
+          <a:xfrm>
+            <a:off x="822960" y="2039112"/>
+            <a:ext cx="457200" cy="457200"/>
+          </a:xfrm>
+          <a:prstGeom prst="rect">
+            <a:avLst/>
+          </a:prstGeom>
+          <a:noFill/>
+          <a:ln/>
+        </p:spPr>
+        <p:txBody>
+          <a:bodyPr wrap="square" rtlCol="0" anchor="ctr"/>
+          <a:lstStyle/>
+          <a:p>
+            <a:pPr marL="0" indent="0" algn="ctr">
+              <a:buNone/>
+            </a:pPr>
+            <a:r>
+              <a:rPr lang="en-US" sz="1600" b="1" dirty="0">
+                <a:solidFill>
+                  <a:srgbClr val="1C7293"/>
+                </a:solidFill>
+                <a:latin typeface="Cambria" pitchFamily="34" charset="0"/>
+                <a:ea typeface="Cambria" pitchFamily="34" charset="-122"/>
+                <a:cs typeface="Cambria" pitchFamily="34" charset="-120"/>
+              </a:rPr>
+              <a:t>1</a:t>
+            </a:r>
+            <a:endParaRPr lang="en-US" sz="1600" dirty="0"/>
+          </a:p>
+        </p:txBody>
+      </p:sp>
+      <p:sp>
+        <p:nvSpPr>
+          <p:cNvPr id="7" name="Text 5">
+            <a:extLst>
+              <a:ext uri="{FF2B5EF4-FFF2-40B4-BE49-F238E27FC236}">
+                <a16:creationId xmlns:a16="http://schemas.microsoft.com/office/drawing/2014/main" id="{16D32681-29DE-6F62-7B0C-BC53F2011744}"/>
+              </a:ext>
+            </a:extLst>
+          </p:cNvPr>
+          <p:cNvSpPr/>
+          <p:nvPr/>
+        </p:nvSpPr>
+        <p:spPr>
+          <a:xfrm>
+            <a:off x="1463040" y="2057400"/>
+            <a:ext cx="4206240" cy="411480"/>
+          </a:xfrm>
+          <a:prstGeom prst="rect">
+            <a:avLst/>
+          </a:prstGeom>
+          <a:noFill/>
+          <a:ln/>
+        </p:spPr>
+        <p:txBody>
+          <a:bodyPr wrap="square" rtlCol="0" anchor="ctr"/>
+          <a:lstStyle/>
+          <a:p>
+            <a:pPr marL="0" indent="0">
+              <a:buNone/>
+            </a:pPr>
+            <a:r>
+              <a:rPr lang="en-US" sz="1500" b="1" dirty="0">
+                <a:solidFill>
+                  <a:srgbClr val="20242B"/>
+                </a:solidFill>
+                <a:latin typeface="Calibri" pitchFamily="34" charset="0"/>
+                <a:ea typeface="Calibri" pitchFamily="34" charset="-122"/>
+                <a:cs typeface="Calibri" pitchFamily="34" charset="-120"/>
+              </a:rPr>
+              <a:t>MCPL</a:t>
+            </a:r>
+            <a:endParaRPr lang="en-US" sz="1500" dirty="0"/>
+          </a:p>
+        </p:txBody>
+      </p:sp>
+      <p:sp>
+        <p:nvSpPr>
+          <p:cNvPr id="8" name="Text 6">
+            <a:extLst>
+              <a:ext uri="{FF2B5EF4-FFF2-40B4-BE49-F238E27FC236}">
+                <a16:creationId xmlns:a16="http://schemas.microsoft.com/office/drawing/2014/main" id="{2C908418-09A1-04E5-D6DA-46B210D8E1C4}"/>
+              </a:ext>
+            </a:extLst>
+          </p:cNvPr>
+          <p:cNvSpPr/>
+          <p:nvPr/>
+        </p:nvSpPr>
+        <p:spPr>
+          <a:xfrm>
+            <a:off x="868680" y="2679192"/>
+            <a:ext cx="4800600" cy="868680"/>
+          </a:xfrm>
+          <a:prstGeom prst="rect">
+            <a:avLst/>
+          </a:prstGeom>
+          <a:noFill/>
+          <a:ln/>
+        </p:spPr>
+        <p:txBody>
+          <a:bodyPr wrap="square" rtlCol="0" anchor="ctr"/>
+          <a:lstStyle/>
+          <a:p>
+            <a:pPr marL="0" indent="0">
+              <a:lnSpc>
+                <a:spcPct val="120000"/>
+              </a:lnSpc>
+              <a:buNone/>
+            </a:pPr>
+            <a:r>
+              <a:rPr lang="en-US" sz="1150" dirty="0">
+                <a:solidFill>
+                  <a:srgbClr val="6E7580"/>
+                </a:solidFill>
+                <a:latin typeface="Calibri" pitchFamily="34" charset="0"/>
+                <a:ea typeface="Calibri" pitchFamily="34" charset="-122"/>
+                <a:cs typeface="Calibri" pitchFamily="34" charset="-120"/>
+              </a:rPr>
+              <a:t>The Monte Carlo Particle List format lets McStas, McXtrace and other transport codes (MCNP, Geant4, PHITS, …) exchange rays and couple simulations together.</a:t>
+            </a:r>
+            <a:endParaRPr lang="en-US" sz="1150" dirty="0"/>
+          </a:p>
+        </p:txBody>
+      </p:sp>
+      <p:sp>
+        <p:nvSpPr>
+          <p:cNvPr id="9" name="Shape 7">
+            <a:extLst>
+              <a:ext uri="{FF2B5EF4-FFF2-40B4-BE49-F238E27FC236}">
+                <a16:creationId xmlns:a16="http://schemas.microsoft.com/office/drawing/2014/main" id="{0ED696C6-7969-A25A-00A8-EEDBB46D65FB}"/>
+              </a:ext>
+            </a:extLst>
+          </p:cNvPr>
+          <p:cNvSpPr/>
+          <p:nvPr/>
+        </p:nvSpPr>
+        <p:spPr>
+          <a:xfrm>
+            <a:off x="6217920" y="1783080"/>
+            <a:ext cx="5394960" cy="1965960"/>
+          </a:xfrm>
+          <a:prstGeom prst="roundRect">
+            <a:avLst>
+              <a:gd name="adj" fmla="val 4186"/>
+            </a:avLst>
+          </a:prstGeom>
+          <a:solidFill>
+            <a:srgbClr val="F7F8FA"/>
+          </a:solidFill>
+          <a:ln/>
+        </p:spPr>
+        <p:txBody>
+          <a:bodyPr/>
+          <a:lstStyle/>
+          <a:p>
+            <a:endParaRPr lang="en-DK"/>
+          </a:p>
+        </p:txBody>
+      </p:sp>
+      <p:sp>
+        <p:nvSpPr>
+          <p:cNvPr id="10" name="Shape 8">
+            <a:extLst>
+              <a:ext uri="{FF2B5EF4-FFF2-40B4-BE49-F238E27FC236}">
+                <a16:creationId xmlns:a16="http://schemas.microsoft.com/office/drawing/2014/main" id="{C9A90C14-3D0B-1BE9-F5B5-FD8B9B52F06F}"/>
+              </a:ext>
+            </a:extLst>
+          </p:cNvPr>
+          <p:cNvSpPr/>
+          <p:nvPr/>
+        </p:nvSpPr>
+        <p:spPr>
+          <a:xfrm>
+            <a:off x="6492240" y="2039112"/>
+            <a:ext cx="457200" cy="457200"/>
+          </a:xfrm>
+          <a:prstGeom prst="ellipse">
+            <a:avLst/>
+          </a:prstGeom>
+          <a:solidFill>
+            <a:srgbClr val="FBEBDA"/>
+          </a:solidFill>
+          <a:ln/>
+        </p:spPr>
+        <p:txBody>
+          <a:bodyPr/>
+          <a:lstStyle/>
+          <a:p>
+            <a:endParaRPr lang="en-DK"/>
+          </a:p>
+        </p:txBody>
+      </p:sp>
+      <p:sp>
+        <p:nvSpPr>
+          <p:cNvPr id="11" name="Text 9">
+            <a:extLst>
+              <a:ext uri="{FF2B5EF4-FFF2-40B4-BE49-F238E27FC236}">
+                <a16:creationId xmlns:a16="http://schemas.microsoft.com/office/drawing/2014/main" id="{09AC604D-DC8C-6C7C-C5C5-8CB33E1B4C81}"/>
+              </a:ext>
+            </a:extLst>
+          </p:cNvPr>
+          <p:cNvSpPr/>
+          <p:nvPr/>
+        </p:nvSpPr>
+        <p:spPr>
+          <a:xfrm>
+            <a:off x="6492240" y="2039112"/>
+            <a:ext cx="457200" cy="457200"/>
+          </a:xfrm>
+          <a:prstGeom prst="rect">
+            <a:avLst/>
+          </a:prstGeom>
+          <a:noFill/>
+          <a:ln/>
+        </p:spPr>
+        <p:txBody>
+          <a:bodyPr wrap="square" rtlCol="0" anchor="ctr"/>
+          <a:lstStyle/>
+          <a:p>
+            <a:pPr marL="0" indent="0" algn="ctr">
+              <a:buNone/>
+            </a:pPr>
+            <a:r>
+              <a:rPr lang="en-US" sz="1600" b="1" dirty="0">
+                <a:solidFill>
+                  <a:srgbClr val="D97A2B"/>
+                </a:solidFill>
+                <a:latin typeface="Cambria" pitchFamily="34" charset="0"/>
+                <a:ea typeface="Cambria" pitchFamily="34" charset="-122"/>
+                <a:cs typeface="Cambria" pitchFamily="34" charset="-120"/>
+              </a:rPr>
+              <a:t>2</a:t>
+            </a:r>
+            <a:endParaRPr lang="en-US" sz="1600" dirty="0"/>
+          </a:p>
+        </p:txBody>
+      </p:sp>
+      <p:sp>
+        <p:nvSpPr>
+          <p:cNvPr id="12" name="Text 10">
+            <a:extLst>
+              <a:ext uri="{FF2B5EF4-FFF2-40B4-BE49-F238E27FC236}">
+                <a16:creationId xmlns:a16="http://schemas.microsoft.com/office/drawing/2014/main" id="{86B53BC2-6461-7D26-7541-B8812BA1D866}"/>
+              </a:ext>
+            </a:extLst>
+          </p:cNvPr>
+          <p:cNvSpPr/>
+          <p:nvPr/>
+        </p:nvSpPr>
+        <p:spPr>
+          <a:xfrm>
+            <a:off x="7132320" y="2057400"/>
+            <a:ext cx="4206240" cy="411480"/>
+          </a:xfrm>
+          <a:prstGeom prst="rect">
+            <a:avLst/>
+          </a:prstGeom>
+          <a:noFill/>
+          <a:ln/>
+        </p:spPr>
+        <p:txBody>
+          <a:bodyPr wrap="square" rtlCol="0" anchor="ctr"/>
+          <a:lstStyle/>
+          <a:p>
+            <a:pPr marL="0" indent="0">
+              <a:buNone/>
+            </a:pPr>
+            <a:r>
+              <a:rPr lang="en-US" sz="1500" b="1" dirty="0">
+                <a:solidFill>
+                  <a:srgbClr val="20242B"/>
+                </a:solidFill>
+                <a:latin typeface="Calibri" pitchFamily="34" charset="0"/>
+                <a:ea typeface="Calibri" pitchFamily="34" charset="-122"/>
+                <a:cs typeface="Calibri" pitchFamily="34" charset="-120"/>
+              </a:rPr>
+              <a:t>Graphical interface</a:t>
+            </a:r>
+            <a:endParaRPr lang="en-US" sz="1500" dirty="0"/>
+          </a:p>
+        </p:txBody>
+      </p:sp>
+      <p:sp>
+        <p:nvSpPr>
+          <p:cNvPr id="13" name="Text 11">
+            <a:extLst>
+              <a:ext uri="{FF2B5EF4-FFF2-40B4-BE49-F238E27FC236}">
+                <a16:creationId xmlns:a16="http://schemas.microsoft.com/office/drawing/2014/main" id="{E7F110B6-0604-B938-8B7B-CC06327517C2}"/>
+              </a:ext>
+            </a:extLst>
+          </p:cNvPr>
+          <p:cNvSpPr/>
+          <p:nvPr/>
+        </p:nvSpPr>
+        <p:spPr>
+          <a:xfrm>
+            <a:off x="6537960" y="2679192"/>
+            <a:ext cx="4800600" cy="868680"/>
+          </a:xfrm>
+          <a:prstGeom prst="rect">
+            <a:avLst/>
+          </a:prstGeom>
+          <a:noFill/>
+          <a:ln/>
+        </p:spPr>
+        <p:txBody>
+          <a:bodyPr wrap="square" rtlCol="0" anchor="ctr"/>
+          <a:lstStyle/>
+          <a:p>
+            <a:pPr marL="0" indent="0">
+              <a:lnSpc>
+                <a:spcPct val="120000"/>
+              </a:lnSpc>
+              <a:buNone/>
+            </a:pPr>
+            <a:r>
+              <a:rPr lang="en-US" sz="1150" dirty="0">
+                <a:solidFill>
+                  <a:srgbClr val="6E7580"/>
+                </a:solidFill>
+                <a:latin typeface="Calibri" pitchFamily="34" charset="0"/>
+                <a:ea typeface="Calibri" pitchFamily="34" charset="-122"/>
+                <a:cs typeface="Calibri" pitchFamily="34" charset="-120"/>
+              </a:rPr>
+              <a:t>A common Python-based GUI supports building, running and browsing results for instruments in either code.</a:t>
+            </a:r>
+            <a:endParaRPr lang="en-US" sz="1150" dirty="0"/>
+          </a:p>
+        </p:txBody>
+      </p:sp>
+      <p:sp>
+        <p:nvSpPr>
+          <p:cNvPr id="14" name="Shape 12">
+            <a:extLst>
+              <a:ext uri="{FF2B5EF4-FFF2-40B4-BE49-F238E27FC236}">
+                <a16:creationId xmlns:a16="http://schemas.microsoft.com/office/drawing/2014/main" id="{26301550-9792-989F-6419-DB959DC4E9C2}"/>
+              </a:ext>
+            </a:extLst>
+          </p:cNvPr>
+          <p:cNvSpPr/>
+          <p:nvPr/>
+        </p:nvSpPr>
+        <p:spPr>
+          <a:xfrm>
+            <a:off x="548640" y="4023360"/>
+            <a:ext cx="5394960" cy="1965960"/>
+          </a:xfrm>
+          <a:prstGeom prst="roundRect">
+            <a:avLst>
+              <a:gd name="adj" fmla="val 4186"/>
+            </a:avLst>
+          </a:prstGeom>
+          <a:solidFill>
+            <a:srgbClr val="F7F8FA"/>
+          </a:solidFill>
+          <a:ln/>
+        </p:spPr>
+        <p:txBody>
+          <a:bodyPr/>
+          <a:lstStyle/>
+          <a:p>
+            <a:endParaRPr lang="en-DK"/>
+          </a:p>
+        </p:txBody>
+      </p:sp>
+      <p:sp>
+        <p:nvSpPr>
+          <p:cNvPr id="15" name="Shape 13">
+            <a:extLst>
+              <a:ext uri="{FF2B5EF4-FFF2-40B4-BE49-F238E27FC236}">
+                <a16:creationId xmlns:a16="http://schemas.microsoft.com/office/drawing/2014/main" id="{6143259B-806C-B80E-CF90-5AD8BEDDE580}"/>
+              </a:ext>
+            </a:extLst>
+          </p:cNvPr>
+          <p:cNvSpPr/>
+          <p:nvPr/>
+        </p:nvSpPr>
+        <p:spPr>
+          <a:xfrm>
+            <a:off x="822960" y="4279392"/>
+            <a:ext cx="457200" cy="457200"/>
+          </a:xfrm>
+          <a:prstGeom prst="ellipse">
+            <a:avLst/>
+          </a:prstGeom>
+          <a:solidFill>
+            <a:srgbClr val="E3EEF2"/>
+          </a:solidFill>
+          <a:ln/>
+        </p:spPr>
+        <p:txBody>
+          <a:bodyPr/>
+          <a:lstStyle/>
+          <a:p>
+            <a:endParaRPr lang="en-DK"/>
+          </a:p>
+        </p:txBody>
+      </p:sp>
+      <p:sp>
+        <p:nvSpPr>
+          <p:cNvPr id="16" name="Text 14">
+            <a:extLst>
+              <a:ext uri="{FF2B5EF4-FFF2-40B4-BE49-F238E27FC236}">
+                <a16:creationId xmlns:a16="http://schemas.microsoft.com/office/drawing/2014/main" id="{E52C3E7B-8885-C080-E8E2-F081E5902BFD}"/>
+              </a:ext>
+            </a:extLst>
+          </p:cNvPr>
+          <p:cNvSpPr/>
+          <p:nvPr/>
+        </p:nvSpPr>
+        <p:spPr>
+          <a:xfrm>
+            <a:off x="822960" y="4279392"/>
+            <a:ext cx="457200" cy="457200"/>
+          </a:xfrm>
+          <a:prstGeom prst="rect">
+            <a:avLst/>
+          </a:prstGeom>
+          <a:noFill/>
+          <a:ln/>
+        </p:spPr>
+        <p:txBody>
+          <a:bodyPr wrap="square" rtlCol="0" anchor="ctr"/>
+          <a:lstStyle/>
+          <a:p>
+            <a:pPr marL="0" indent="0" algn="ctr">
+              <a:buNone/>
+            </a:pPr>
+            <a:r>
+              <a:rPr lang="en-US" sz="1600" b="1" dirty="0">
+                <a:solidFill>
+                  <a:srgbClr val="1C7293"/>
+                </a:solidFill>
+                <a:latin typeface="Cambria" pitchFamily="34" charset="0"/>
+                <a:ea typeface="Cambria" pitchFamily="34" charset="-122"/>
+                <a:cs typeface="Cambria" pitchFamily="34" charset="-120"/>
+              </a:rPr>
+              <a:t>3</a:t>
+            </a:r>
+            <a:endParaRPr lang="en-US" sz="1600" dirty="0"/>
+          </a:p>
+        </p:txBody>
+      </p:sp>
+      <p:sp>
+        <p:nvSpPr>
+          <p:cNvPr id="17" name="Text 15">
+            <a:extLst>
+              <a:ext uri="{FF2B5EF4-FFF2-40B4-BE49-F238E27FC236}">
+                <a16:creationId xmlns:a16="http://schemas.microsoft.com/office/drawing/2014/main" id="{2931158D-E912-1AAA-BB9C-D732B5BB836B}"/>
+              </a:ext>
+            </a:extLst>
+          </p:cNvPr>
+          <p:cNvSpPr/>
+          <p:nvPr/>
+        </p:nvSpPr>
+        <p:spPr>
+          <a:xfrm>
+            <a:off x="1463040" y="4297680"/>
+            <a:ext cx="4206240" cy="411480"/>
+          </a:xfrm>
+          <a:prstGeom prst="rect">
+            <a:avLst/>
+          </a:prstGeom>
+          <a:noFill/>
+          <a:ln/>
+        </p:spPr>
+        <p:txBody>
+          <a:bodyPr wrap="square" rtlCol="0" anchor="ctr"/>
+          <a:lstStyle/>
+          <a:p>
+            <a:pPr marL="0" indent="0">
+              <a:buNone/>
+            </a:pPr>
+            <a:r>
+              <a:rPr lang="en-US" sz="1500" b="1" dirty="0">
+                <a:solidFill>
+                  <a:srgbClr val="20242B"/>
+                </a:solidFill>
+                <a:latin typeface="Calibri" pitchFamily="34" charset="0"/>
+                <a:ea typeface="Calibri" pitchFamily="34" charset="-122"/>
+                <a:cs typeface="Calibri" pitchFamily="34" charset="-120"/>
+              </a:rPr>
+              <a:t>Plotting tools</a:t>
+            </a:r>
+            <a:endParaRPr lang="en-US" sz="1500" dirty="0"/>
+          </a:p>
+        </p:txBody>
+      </p:sp>
+      <p:sp>
+        <p:nvSpPr>
+          <p:cNvPr id="18" name="Text 16">
+            <a:extLst>
+              <a:ext uri="{FF2B5EF4-FFF2-40B4-BE49-F238E27FC236}">
+                <a16:creationId xmlns:a16="http://schemas.microsoft.com/office/drawing/2014/main" id="{1861F43E-E398-53AB-AC36-281B6BDF1158}"/>
+              </a:ext>
+            </a:extLst>
+          </p:cNvPr>
+          <p:cNvSpPr/>
+          <p:nvPr/>
+        </p:nvSpPr>
+        <p:spPr>
+          <a:xfrm>
+            <a:off x="868680" y="4919472"/>
+            <a:ext cx="4800600" cy="868680"/>
+          </a:xfrm>
+          <a:prstGeom prst="rect">
+            <a:avLst/>
+          </a:prstGeom>
+          <a:noFill/>
+          <a:ln/>
+        </p:spPr>
+        <p:txBody>
+          <a:bodyPr wrap="square" rtlCol="0" anchor="ctr"/>
+          <a:lstStyle/>
+          <a:p>
+            <a:pPr marL="0" indent="0">
+              <a:lnSpc>
+                <a:spcPct val="120000"/>
+              </a:lnSpc>
+              <a:buNone/>
+            </a:pPr>
+            <a:r>
+              <a:rPr lang="en-US" sz="1150" dirty="0">
+                <a:solidFill>
+                  <a:srgbClr val="6E7580"/>
+                </a:solidFill>
+                <a:latin typeface="Calibri" pitchFamily="34" charset="0"/>
+                <a:ea typeface="Calibri" pitchFamily="34" charset="-122"/>
+                <a:cs typeface="Calibri" pitchFamily="34" charset="-120"/>
+              </a:rPr>
+              <a:t>A shared plotting toolchain (HTML/D3, pyqtgraph, matplotlib backends) visualises monitor output from both packages.</a:t>
+            </a:r>
+            <a:endParaRPr lang="en-US" sz="1150" dirty="0"/>
+          </a:p>
+        </p:txBody>
+      </p:sp>
+      <p:sp>
+        <p:nvSpPr>
+          <p:cNvPr id="19" name="Shape 17">
+            <a:extLst>
+              <a:ext uri="{FF2B5EF4-FFF2-40B4-BE49-F238E27FC236}">
+                <a16:creationId xmlns:a16="http://schemas.microsoft.com/office/drawing/2014/main" id="{151A815A-0235-6804-4D92-E7D056058CE3}"/>
+              </a:ext>
+            </a:extLst>
+          </p:cNvPr>
+          <p:cNvSpPr/>
+          <p:nvPr/>
+        </p:nvSpPr>
+        <p:spPr>
+          <a:xfrm>
+            <a:off x="6217920" y="4023360"/>
+            <a:ext cx="5394960" cy="1965960"/>
+          </a:xfrm>
+          <a:prstGeom prst="roundRect">
+            <a:avLst>
+              <a:gd name="adj" fmla="val 4186"/>
+            </a:avLst>
+          </a:prstGeom>
+          <a:solidFill>
+            <a:srgbClr val="F7F8FA"/>
+          </a:solidFill>
+          <a:ln/>
+        </p:spPr>
+        <p:txBody>
+          <a:bodyPr/>
+          <a:lstStyle/>
+          <a:p>
+            <a:endParaRPr lang="en-DK"/>
+          </a:p>
+        </p:txBody>
+      </p:sp>
+      <p:sp>
+        <p:nvSpPr>
+          <p:cNvPr id="20" name="Shape 18">
+            <a:extLst>
+              <a:ext uri="{FF2B5EF4-FFF2-40B4-BE49-F238E27FC236}">
+                <a16:creationId xmlns:a16="http://schemas.microsoft.com/office/drawing/2014/main" id="{AFD6CC0E-2CBF-3E08-CC02-F5C7AF34A18A}"/>
+              </a:ext>
+            </a:extLst>
+          </p:cNvPr>
+          <p:cNvSpPr/>
+          <p:nvPr/>
+        </p:nvSpPr>
+        <p:spPr>
+          <a:xfrm>
+            <a:off x="6492240" y="4279392"/>
+            <a:ext cx="457200" cy="457200"/>
+          </a:xfrm>
+          <a:prstGeom prst="ellipse">
+            <a:avLst/>
+          </a:prstGeom>
+          <a:solidFill>
+            <a:srgbClr val="FBEBDA"/>
+          </a:solidFill>
+          <a:ln/>
+        </p:spPr>
+        <p:txBody>
+          <a:bodyPr/>
+          <a:lstStyle/>
+          <a:p>
+            <a:endParaRPr lang="en-DK"/>
+          </a:p>
+        </p:txBody>
+      </p:sp>
+      <p:sp>
+        <p:nvSpPr>
+          <p:cNvPr id="21" name="Text 19">
+            <a:extLst>
+              <a:ext uri="{FF2B5EF4-FFF2-40B4-BE49-F238E27FC236}">
+                <a16:creationId xmlns:a16="http://schemas.microsoft.com/office/drawing/2014/main" id="{263ABA2A-DCED-7DC1-72B7-56AC31985EC8}"/>
+              </a:ext>
+            </a:extLst>
+          </p:cNvPr>
+          <p:cNvSpPr/>
+          <p:nvPr/>
+        </p:nvSpPr>
+        <p:spPr>
+          <a:xfrm>
+            <a:off x="6492240" y="4279392"/>
+            <a:ext cx="457200" cy="457200"/>
+          </a:xfrm>
+          <a:prstGeom prst="rect">
+            <a:avLst/>
+          </a:prstGeom>
+          <a:noFill/>
+          <a:ln/>
+        </p:spPr>
+        <p:txBody>
+          <a:bodyPr wrap="square" rtlCol="0" anchor="ctr"/>
+          <a:lstStyle/>
+          <a:p>
+            <a:pPr marL="0" indent="0" algn="ctr">
+              <a:buNone/>
+            </a:pPr>
+            <a:r>
+              <a:rPr lang="en-US" sz="1600" b="1" dirty="0">
+                <a:solidFill>
+                  <a:srgbClr val="D97A2B"/>
+                </a:solidFill>
+                <a:latin typeface="Cambria" pitchFamily="34" charset="0"/>
+                <a:ea typeface="Cambria" pitchFamily="34" charset="-122"/>
+                <a:cs typeface="Cambria" pitchFamily="34" charset="-120"/>
+              </a:rPr>
+              <a:t>4</a:t>
+            </a:r>
+            <a:endParaRPr lang="en-US" sz="1600" dirty="0"/>
+          </a:p>
+        </p:txBody>
+      </p:sp>
+      <p:sp>
+        <p:nvSpPr>
+          <p:cNvPr id="22" name="Text 20">
+            <a:extLst>
+              <a:ext uri="{FF2B5EF4-FFF2-40B4-BE49-F238E27FC236}">
+                <a16:creationId xmlns:a16="http://schemas.microsoft.com/office/drawing/2014/main" id="{46A4BC67-F2AC-D2C0-71B1-1E502058777F}"/>
+              </a:ext>
+            </a:extLst>
+          </p:cNvPr>
+          <p:cNvSpPr/>
+          <p:nvPr/>
+        </p:nvSpPr>
+        <p:spPr>
+          <a:xfrm>
+            <a:off x="7132320" y="4297680"/>
+            <a:ext cx="4206240" cy="411480"/>
+          </a:xfrm>
+          <a:prstGeom prst="rect">
+            <a:avLst/>
+          </a:prstGeom>
+          <a:noFill/>
+          <a:ln/>
+        </p:spPr>
+        <p:txBody>
+          <a:bodyPr wrap="square" rtlCol="0" anchor="ctr"/>
+          <a:lstStyle/>
+          <a:p>
+            <a:pPr marL="0" indent="0">
+              <a:buNone/>
+            </a:pPr>
+            <a:r>
+              <a:rPr lang="en-US" sz="1500" b="1" dirty="0">
+                <a:solidFill>
+                  <a:srgbClr val="20242B"/>
+                </a:solidFill>
+                <a:latin typeface="Calibri" pitchFamily="34" charset="0"/>
+                <a:ea typeface="Calibri" pitchFamily="34" charset="-122"/>
+                <a:cs typeface="Calibri" pitchFamily="34" charset="-120"/>
+              </a:rPr>
+              <a:t>Packaging</a:t>
+            </a:r>
+            <a:endParaRPr lang="en-US" sz="1500" dirty="0"/>
+          </a:p>
+        </p:txBody>
+      </p:sp>
+      <p:sp>
+        <p:nvSpPr>
+          <p:cNvPr id="23" name="Text 21">
+            <a:extLst>
+              <a:ext uri="{FF2B5EF4-FFF2-40B4-BE49-F238E27FC236}">
+                <a16:creationId xmlns:a16="http://schemas.microsoft.com/office/drawing/2014/main" id="{BB6D66E6-52FA-6E3B-C0B6-304FB679E3C3}"/>
+              </a:ext>
+            </a:extLst>
+          </p:cNvPr>
+          <p:cNvSpPr/>
+          <p:nvPr/>
+        </p:nvSpPr>
+        <p:spPr>
+          <a:xfrm>
+            <a:off x="6537960" y="4919472"/>
+            <a:ext cx="4800600" cy="868680"/>
+          </a:xfrm>
+          <a:prstGeom prst="rect">
+            <a:avLst/>
+          </a:prstGeom>
+          <a:noFill/>
+          <a:ln/>
+        </p:spPr>
+        <p:txBody>
+          <a:bodyPr wrap="square" rtlCol="0" anchor="ctr"/>
+          <a:lstStyle/>
+          <a:p>
+            <a:pPr marL="0" indent="0">
+              <a:lnSpc>
+                <a:spcPct val="120000"/>
+              </a:lnSpc>
+              <a:buNone/>
+            </a:pPr>
+            <a:r>
+              <a:rPr lang="en-US" sz="1150" dirty="0">
+                <a:solidFill>
+                  <a:srgbClr val="6E7580"/>
+                </a:solidFill>
+                <a:latin typeface="Calibri" pitchFamily="34" charset="0"/>
+                <a:ea typeface="Calibri" pitchFamily="34" charset="-122"/>
+                <a:cs typeface="Calibri" pitchFamily="34" charset="-120"/>
+              </a:rPr>
+              <a:t>Conda-forge distributions and cross-platform installers keep both codes easy to install on Linux, macOS and Windows.</a:t>
+            </a:r>
+            <a:endParaRPr lang="en-US" sz="1150" dirty="0"/>
+          </a:p>
+        </p:txBody>
+      </p:sp>
+      <p:sp>
+        <p:nvSpPr>
+          <p:cNvPr id="24" name="Text 22">
+            <a:extLst>
+              <a:ext uri="{FF2B5EF4-FFF2-40B4-BE49-F238E27FC236}">
+                <a16:creationId xmlns:a16="http://schemas.microsoft.com/office/drawing/2014/main" id="{D3D6E573-0B95-A516-3E64-1D7D6DE027B8}"/>
+              </a:ext>
+            </a:extLst>
+          </p:cNvPr>
+          <p:cNvSpPr/>
+          <p:nvPr/>
+        </p:nvSpPr>
+        <p:spPr>
+          <a:xfrm>
+            <a:off x="548640" y="6446520"/>
+            <a:ext cx="6400800" cy="274320"/>
+          </a:xfrm>
+          <a:prstGeom prst="rect">
+            <a:avLst/>
+          </a:prstGeom>
+          <a:noFill/>
+          <a:ln/>
+        </p:spPr>
+        <p:txBody>
+          <a:bodyPr wrap="square" rtlCol="0" anchor="ctr"/>
+          <a:lstStyle/>
+          <a:p>
+            <a:pPr marL="0" indent="0" algn="l">
+              <a:buNone/>
+            </a:pPr>
+            <a:r>
+              <a:rPr lang="en-US" sz="900" dirty="0">
+                <a:solidFill>
+                  <a:srgbClr val="6E7580"/>
+                </a:solidFill>
+                <a:latin typeface="Calibri" pitchFamily="34" charset="0"/>
+                <a:ea typeface="Calibri" pitchFamily="34" charset="-122"/>
+                <a:cs typeface="Calibri" pitchFamily="34" charset="-120"/>
+              </a:rPr>
+              <a:t>McStas &amp; McXtrace  ·  Common Introduction</a:t>
+            </a:r>
+            <a:endParaRPr lang="en-US" sz="900" dirty="0"/>
+          </a:p>
+        </p:txBody>
+      </p:sp>
+      <p:sp>
+        <p:nvSpPr>
+          <p:cNvPr id="25" name="Text 23">
+            <a:extLst>
+              <a:ext uri="{FF2B5EF4-FFF2-40B4-BE49-F238E27FC236}">
+                <a16:creationId xmlns:a16="http://schemas.microsoft.com/office/drawing/2014/main" id="{4BB8E327-FF44-5C30-D4CC-8454C3D56A7E}"/>
+              </a:ext>
+            </a:extLst>
+          </p:cNvPr>
+          <p:cNvSpPr/>
+          <p:nvPr/>
+        </p:nvSpPr>
+        <p:spPr>
+          <a:xfrm>
+            <a:off x="11185855" y="6446520"/>
+            <a:ext cx="457200" cy="274320"/>
+          </a:xfrm>
+          <a:prstGeom prst="rect">
+            <a:avLst/>
+          </a:prstGeom>
+          <a:noFill/>
+          <a:ln/>
+        </p:spPr>
+        <p:txBody>
+          <a:bodyPr wrap="square" rtlCol="0" anchor="ctr"/>
+          <a:lstStyle/>
+          <a:p>
+            <a:pPr marL="0" indent="0" algn="r">
+              <a:buNone/>
+            </a:pPr>
+            <a:r>
+              <a:rPr lang="en-US" sz="900">
+                <a:solidFill>
+                  <a:srgbClr val="6E7580"/>
+                </a:solidFill>
+                <a:latin typeface="Calibri"/>
+                <a:ea typeface="Calibri" pitchFamily="34" charset="-122"/>
+                <a:cs typeface="Calibri"/>
+              </a:rPr>
+              <a:t>15</a:t>
+            </a:r>
+            <a:endParaRPr lang="en-US" sz="900" dirty="0">
+              <a:solidFill>
+                <a:srgbClr val="6E7580"/>
+              </a:solidFill>
+              <a:latin typeface="Calibri"/>
+              <a:cs typeface="Calibri"/>
+            </a:endParaRPr>
+          </a:p>
+        </p:txBody>
+      </p:sp>
+      <p:pic>
+        <p:nvPicPr>
+          <p:cNvPr id="26" name="Copied Picture 26">
+            <a:extLst>
+              <a:ext uri="{FF2B5EF4-FFF2-40B4-BE49-F238E27FC236}">
+                <a16:creationId xmlns:a16="http://schemas.microsoft.com/office/drawing/2014/main" id="{025F2B64-0FD4-A5CA-98A0-FD1D0364BEE7}"/>
+              </a:ext>
+            </a:extLst>
+          </p:cNvPr>
+          <p:cNvPicPr>
+            <a:picLocks noChangeAspect="1"/>
+          </p:cNvPicPr>
+          <p:nvPr/>
+        </p:nvPicPr>
+        <p:blipFill>
+          <a:blip r:embed="rId3"/>
+          <a:srcRect l="11719" t="16994"/>
+          <a:stretch>
+            <a:fillRect/>
+          </a:stretch>
+        </p:blipFill>
+        <p:spPr>
+          <a:xfrm>
+            <a:off x="10375900" y="355600"/>
+            <a:ext cx="1270000" cy="651510"/>
+          </a:xfrm>
+          <a:prstGeom prst="rect">
+            <a:avLst/>
+          </a:prstGeom>
+        </p:spPr>
+      </p:pic>
+      <p:pic>
+        <p:nvPicPr>
+          <p:cNvPr id="27" name="Picture 26">
+            <a:extLst>
+              <a:ext uri="{FF2B5EF4-FFF2-40B4-BE49-F238E27FC236}">
+                <a16:creationId xmlns:a16="http://schemas.microsoft.com/office/drawing/2014/main" id="{2A684F2A-A376-5FB1-633C-BC78F0E0E4CF}"/>
+              </a:ext>
+            </a:extLst>
+          </p:cNvPr>
+          <p:cNvPicPr>
+            <a:picLocks noChangeAspect="1"/>
+          </p:cNvPicPr>
+          <p:nvPr/>
+        </p:nvPicPr>
+        <p:blipFill>
+          <a:blip r:embed="rId4"/>
+          <a:stretch>
+            <a:fillRect/>
+          </a:stretch>
+        </p:blipFill>
+        <p:spPr>
+          <a:xfrm>
+            <a:off x="9161083" y="6473952"/>
+            <a:ext cx="2150018" cy="319035"/>
+          </a:xfrm>
+          <a:prstGeom prst="rect">
+            <a:avLst/>
+          </a:prstGeom>
+        </p:spPr>
+      </p:pic>
+    </p:spTree>
+    <p:extLst>
+      <p:ext uri="{BB962C8B-B14F-4D97-AF65-F5344CB8AC3E}">
+        <p14:creationId xmlns:p14="http://schemas.microsoft.com/office/powerpoint/2010/main" val="2853761707"/>
+      </p:ext>
+    </p:extLst>
+  </p:cSld>
+  <p:clrMapOvr>
+    <a:masterClrMapping/>
+  </p:clrMapOvr>
+</p:sld>
+</file>
+
+<file path=ppt/slides/slide16.xml><?xml version="1.0" encoding="utf-8"?>
+<p:sld xmlns:a="http://schemas.openxmlformats.org/drawingml/2006/main" xmlns:r="http://schemas.openxmlformats.org/officeDocument/2006/relationships" xmlns:p="http://schemas.openxmlformats.org/presentationml/2006/main">
   <p:cSld name="Slide 14">
     <p:bg>
       <p:bgPr>
@@ -8127,7 +9515,7 @@
                 <a:ea typeface="Calibri" pitchFamily="34" charset="-122"/>
                 <a:cs typeface="Calibri" pitchFamily="34" charset="-120"/>
               </a:rPr>
-              <a:t>ECOSYSTEM</a:t>
+              <a:t>Tools</a:t>
             </a:r>
             <a:endParaRPr lang="en-US" sz="1200" dirty="0"/>
           </a:p>
@@ -8142,7 +9530,7 @@
         <p:spPr>
           <a:xfrm>
             <a:off x="548640" y="658368"/>
-            <a:ext cx="11064240" cy="822960"/>
+            <a:ext cx="11064240" cy="466470"/>
           </a:xfrm>
           <a:prstGeom prst="rect">
             <a:avLst/>
@@ -8166,713 +9554,9 @@
                 <a:ea typeface="Cambria" pitchFamily="34" charset="-122"/>
                 <a:cs typeface="Cambria" pitchFamily="34" charset="-120"/>
               </a:rPr>
-              <a:t>A shared, interoperable ecosystem</a:t>
+              <a:t>Shared interfaces, tools and utilities</a:t>
             </a:r>
             <a:endParaRPr lang="en-US" sz="3000" dirty="0"/>
-          </a:p>
-        </p:txBody>
-      </p:sp>
-      <p:sp>
-        <p:nvSpPr>
-          <p:cNvPr id="4" name="Shape 2"/>
-          <p:cNvSpPr/>
-          <p:nvPr/>
-        </p:nvSpPr>
-        <p:spPr>
-          <a:xfrm>
-            <a:off x="548640" y="1783080"/>
-            <a:ext cx="5394960" cy="1965960"/>
-          </a:xfrm>
-          <a:prstGeom prst="roundRect">
-            <a:avLst>
-              <a:gd name="adj" fmla="val 4186"/>
-            </a:avLst>
-          </a:prstGeom>
-          <a:solidFill>
-            <a:srgbClr val="F7F8FA"/>
-          </a:solidFill>
-          <a:ln/>
-        </p:spPr>
-        <p:txBody>
-          <a:bodyPr/>
-          <a:lstStyle/>
-          <a:p>
-            <a:endParaRPr lang="en-DK"/>
-          </a:p>
-        </p:txBody>
-      </p:sp>
-      <p:sp>
-        <p:nvSpPr>
-          <p:cNvPr id="5" name="Shape 3"/>
-          <p:cNvSpPr/>
-          <p:nvPr/>
-        </p:nvSpPr>
-        <p:spPr>
-          <a:xfrm>
-            <a:off x="822960" y="2039112"/>
-            <a:ext cx="457200" cy="457200"/>
-          </a:xfrm>
-          <a:prstGeom prst="ellipse">
-            <a:avLst/>
-          </a:prstGeom>
-          <a:solidFill>
-            <a:srgbClr val="E3EEF2"/>
-          </a:solidFill>
-          <a:ln/>
-        </p:spPr>
-        <p:txBody>
-          <a:bodyPr/>
-          <a:lstStyle/>
-          <a:p>
-            <a:endParaRPr lang="en-DK"/>
-          </a:p>
-        </p:txBody>
-      </p:sp>
-      <p:sp>
-        <p:nvSpPr>
-          <p:cNvPr id="6" name="Text 4"/>
-          <p:cNvSpPr/>
-          <p:nvPr/>
-        </p:nvSpPr>
-        <p:spPr>
-          <a:xfrm>
-            <a:off x="822960" y="2039112"/>
-            <a:ext cx="457200" cy="457200"/>
-          </a:xfrm>
-          <a:prstGeom prst="rect">
-            <a:avLst/>
-          </a:prstGeom>
-          <a:noFill/>
-          <a:ln/>
-        </p:spPr>
-        <p:txBody>
-          <a:bodyPr wrap="square" rtlCol="0" anchor="ctr"/>
-          <a:lstStyle/>
-          <a:p>
-            <a:pPr marL="0" indent="0" algn="ctr">
-              <a:buNone/>
-            </a:pPr>
-            <a:r>
-              <a:rPr lang="en-US" sz="1600" b="1" dirty="0">
-                <a:solidFill>
-                  <a:srgbClr val="1C7293"/>
-                </a:solidFill>
-                <a:latin typeface="Cambria" pitchFamily="34" charset="0"/>
-                <a:ea typeface="Cambria" pitchFamily="34" charset="-122"/>
-                <a:cs typeface="Cambria" pitchFamily="34" charset="-120"/>
-              </a:rPr>
-              <a:t>1</a:t>
-            </a:r>
-            <a:endParaRPr lang="en-US" sz="1600" dirty="0"/>
-          </a:p>
-        </p:txBody>
-      </p:sp>
-      <p:sp>
-        <p:nvSpPr>
-          <p:cNvPr id="7" name="Text 5"/>
-          <p:cNvSpPr/>
-          <p:nvPr/>
-        </p:nvSpPr>
-        <p:spPr>
-          <a:xfrm>
-            <a:off x="1463040" y="2057400"/>
-            <a:ext cx="4206240" cy="411480"/>
-          </a:xfrm>
-          <a:prstGeom prst="rect">
-            <a:avLst/>
-          </a:prstGeom>
-          <a:noFill/>
-          <a:ln/>
-        </p:spPr>
-        <p:txBody>
-          <a:bodyPr wrap="square" rtlCol="0" anchor="ctr"/>
-          <a:lstStyle/>
-          <a:p>
-            <a:pPr marL="0" indent="0">
-              <a:buNone/>
-            </a:pPr>
-            <a:r>
-              <a:rPr lang="en-US" sz="1500" b="1" dirty="0">
-                <a:solidFill>
-                  <a:srgbClr val="20242B"/>
-                </a:solidFill>
-                <a:latin typeface="Calibri" pitchFamily="34" charset="0"/>
-                <a:ea typeface="Calibri" pitchFamily="34" charset="-122"/>
-                <a:cs typeface="Calibri" pitchFamily="34" charset="-120"/>
-              </a:rPr>
-              <a:t>MCPL</a:t>
-            </a:r>
-            <a:endParaRPr lang="en-US" sz="1500" dirty="0"/>
-          </a:p>
-        </p:txBody>
-      </p:sp>
-      <p:sp>
-        <p:nvSpPr>
-          <p:cNvPr id="8" name="Text 6"/>
-          <p:cNvSpPr/>
-          <p:nvPr/>
-        </p:nvSpPr>
-        <p:spPr>
-          <a:xfrm>
-            <a:off x="868680" y="2679192"/>
-            <a:ext cx="4800600" cy="868680"/>
-          </a:xfrm>
-          <a:prstGeom prst="rect">
-            <a:avLst/>
-          </a:prstGeom>
-          <a:noFill/>
-          <a:ln/>
-        </p:spPr>
-        <p:txBody>
-          <a:bodyPr wrap="square" rtlCol="0" anchor="ctr"/>
-          <a:lstStyle/>
-          <a:p>
-            <a:pPr marL="0" indent="0">
-              <a:lnSpc>
-                <a:spcPct val="120000"/>
-              </a:lnSpc>
-              <a:buNone/>
-            </a:pPr>
-            <a:r>
-              <a:rPr lang="en-US" sz="1150" dirty="0">
-                <a:solidFill>
-                  <a:srgbClr val="6E7580"/>
-                </a:solidFill>
-                <a:latin typeface="Calibri" pitchFamily="34" charset="0"/>
-                <a:ea typeface="Calibri" pitchFamily="34" charset="-122"/>
-                <a:cs typeface="Calibri" pitchFamily="34" charset="-120"/>
-              </a:rPr>
-              <a:t>The Monte Carlo Particle List format lets McStas, McXtrace and other transport codes (MCNP, Geant4, PHITS, …) exchange rays and couple simulations together.</a:t>
-            </a:r>
-            <a:endParaRPr lang="en-US" sz="1150" dirty="0"/>
-          </a:p>
-        </p:txBody>
-      </p:sp>
-      <p:sp>
-        <p:nvSpPr>
-          <p:cNvPr id="9" name="Shape 7"/>
-          <p:cNvSpPr/>
-          <p:nvPr/>
-        </p:nvSpPr>
-        <p:spPr>
-          <a:xfrm>
-            <a:off x="6217920" y="1783080"/>
-            <a:ext cx="5394960" cy="1965960"/>
-          </a:xfrm>
-          <a:prstGeom prst="roundRect">
-            <a:avLst>
-              <a:gd name="adj" fmla="val 4186"/>
-            </a:avLst>
-          </a:prstGeom>
-          <a:solidFill>
-            <a:srgbClr val="F7F8FA"/>
-          </a:solidFill>
-          <a:ln/>
-        </p:spPr>
-        <p:txBody>
-          <a:bodyPr/>
-          <a:lstStyle/>
-          <a:p>
-            <a:endParaRPr lang="en-DK"/>
-          </a:p>
-        </p:txBody>
-      </p:sp>
-      <p:sp>
-        <p:nvSpPr>
-          <p:cNvPr id="10" name="Shape 8"/>
-          <p:cNvSpPr/>
-          <p:nvPr/>
-        </p:nvSpPr>
-        <p:spPr>
-          <a:xfrm>
-            <a:off x="6492240" y="2039112"/>
-            <a:ext cx="457200" cy="457200"/>
-          </a:xfrm>
-          <a:prstGeom prst="ellipse">
-            <a:avLst/>
-          </a:prstGeom>
-          <a:solidFill>
-            <a:srgbClr val="FBEBDA"/>
-          </a:solidFill>
-          <a:ln/>
-        </p:spPr>
-        <p:txBody>
-          <a:bodyPr/>
-          <a:lstStyle/>
-          <a:p>
-            <a:endParaRPr lang="en-DK"/>
-          </a:p>
-        </p:txBody>
-      </p:sp>
-      <p:sp>
-        <p:nvSpPr>
-          <p:cNvPr id="11" name="Text 9"/>
-          <p:cNvSpPr/>
-          <p:nvPr/>
-        </p:nvSpPr>
-        <p:spPr>
-          <a:xfrm>
-            <a:off x="6492240" y="2039112"/>
-            <a:ext cx="457200" cy="457200"/>
-          </a:xfrm>
-          <a:prstGeom prst="rect">
-            <a:avLst/>
-          </a:prstGeom>
-          <a:noFill/>
-          <a:ln/>
-        </p:spPr>
-        <p:txBody>
-          <a:bodyPr wrap="square" rtlCol="0" anchor="ctr"/>
-          <a:lstStyle/>
-          <a:p>
-            <a:pPr marL="0" indent="0" algn="ctr">
-              <a:buNone/>
-            </a:pPr>
-            <a:r>
-              <a:rPr lang="en-US" sz="1600" b="1" dirty="0">
-                <a:solidFill>
-                  <a:srgbClr val="D97A2B"/>
-                </a:solidFill>
-                <a:latin typeface="Cambria" pitchFamily="34" charset="0"/>
-                <a:ea typeface="Cambria" pitchFamily="34" charset="-122"/>
-                <a:cs typeface="Cambria" pitchFamily="34" charset="-120"/>
-              </a:rPr>
-              <a:t>2</a:t>
-            </a:r>
-            <a:endParaRPr lang="en-US" sz="1600" dirty="0"/>
-          </a:p>
-        </p:txBody>
-      </p:sp>
-      <p:sp>
-        <p:nvSpPr>
-          <p:cNvPr id="12" name="Text 10"/>
-          <p:cNvSpPr/>
-          <p:nvPr/>
-        </p:nvSpPr>
-        <p:spPr>
-          <a:xfrm>
-            <a:off x="7132320" y="2057400"/>
-            <a:ext cx="4206240" cy="411480"/>
-          </a:xfrm>
-          <a:prstGeom prst="rect">
-            <a:avLst/>
-          </a:prstGeom>
-          <a:noFill/>
-          <a:ln/>
-        </p:spPr>
-        <p:txBody>
-          <a:bodyPr wrap="square" rtlCol="0" anchor="ctr"/>
-          <a:lstStyle/>
-          <a:p>
-            <a:pPr marL="0" indent="0">
-              <a:buNone/>
-            </a:pPr>
-            <a:r>
-              <a:rPr lang="en-US" sz="1500" b="1" dirty="0">
-                <a:solidFill>
-                  <a:srgbClr val="20242B"/>
-                </a:solidFill>
-                <a:latin typeface="Calibri" pitchFamily="34" charset="0"/>
-                <a:ea typeface="Calibri" pitchFamily="34" charset="-122"/>
-                <a:cs typeface="Calibri" pitchFamily="34" charset="-120"/>
-              </a:rPr>
-              <a:t>Graphical interface</a:t>
-            </a:r>
-            <a:endParaRPr lang="en-US" sz="1500" dirty="0"/>
-          </a:p>
-        </p:txBody>
-      </p:sp>
-      <p:sp>
-        <p:nvSpPr>
-          <p:cNvPr id="13" name="Text 11"/>
-          <p:cNvSpPr/>
-          <p:nvPr/>
-        </p:nvSpPr>
-        <p:spPr>
-          <a:xfrm>
-            <a:off x="6537960" y="2679192"/>
-            <a:ext cx="4800600" cy="868680"/>
-          </a:xfrm>
-          <a:prstGeom prst="rect">
-            <a:avLst/>
-          </a:prstGeom>
-          <a:noFill/>
-          <a:ln/>
-        </p:spPr>
-        <p:txBody>
-          <a:bodyPr wrap="square" rtlCol="0" anchor="ctr"/>
-          <a:lstStyle/>
-          <a:p>
-            <a:pPr marL="0" indent="0">
-              <a:lnSpc>
-                <a:spcPct val="120000"/>
-              </a:lnSpc>
-              <a:buNone/>
-            </a:pPr>
-            <a:r>
-              <a:rPr lang="en-US" sz="1150" dirty="0">
-                <a:solidFill>
-                  <a:srgbClr val="6E7580"/>
-                </a:solidFill>
-                <a:latin typeface="Calibri" pitchFamily="34" charset="0"/>
-                <a:ea typeface="Calibri" pitchFamily="34" charset="-122"/>
-                <a:cs typeface="Calibri" pitchFamily="34" charset="-120"/>
-              </a:rPr>
-              <a:t>A common Python-based GUI supports building, running and browsing results for instruments in either code.</a:t>
-            </a:r>
-            <a:endParaRPr lang="en-US" sz="1150" dirty="0"/>
-          </a:p>
-        </p:txBody>
-      </p:sp>
-      <p:sp>
-        <p:nvSpPr>
-          <p:cNvPr id="14" name="Shape 12"/>
-          <p:cNvSpPr/>
-          <p:nvPr/>
-        </p:nvSpPr>
-        <p:spPr>
-          <a:xfrm>
-            <a:off x="548640" y="4023360"/>
-            <a:ext cx="5394960" cy="1965960"/>
-          </a:xfrm>
-          <a:prstGeom prst="roundRect">
-            <a:avLst>
-              <a:gd name="adj" fmla="val 4186"/>
-            </a:avLst>
-          </a:prstGeom>
-          <a:solidFill>
-            <a:srgbClr val="F7F8FA"/>
-          </a:solidFill>
-          <a:ln/>
-        </p:spPr>
-        <p:txBody>
-          <a:bodyPr/>
-          <a:lstStyle/>
-          <a:p>
-            <a:endParaRPr lang="en-DK"/>
-          </a:p>
-        </p:txBody>
-      </p:sp>
-      <p:sp>
-        <p:nvSpPr>
-          <p:cNvPr id="15" name="Shape 13"/>
-          <p:cNvSpPr/>
-          <p:nvPr/>
-        </p:nvSpPr>
-        <p:spPr>
-          <a:xfrm>
-            <a:off x="822960" y="4279392"/>
-            <a:ext cx="457200" cy="457200"/>
-          </a:xfrm>
-          <a:prstGeom prst="ellipse">
-            <a:avLst/>
-          </a:prstGeom>
-          <a:solidFill>
-            <a:srgbClr val="E3EEF2"/>
-          </a:solidFill>
-          <a:ln/>
-        </p:spPr>
-        <p:txBody>
-          <a:bodyPr/>
-          <a:lstStyle/>
-          <a:p>
-            <a:endParaRPr lang="en-DK"/>
-          </a:p>
-        </p:txBody>
-      </p:sp>
-      <p:sp>
-        <p:nvSpPr>
-          <p:cNvPr id="16" name="Text 14"/>
-          <p:cNvSpPr/>
-          <p:nvPr/>
-        </p:nvSpPr>
-        <p:spPr>
-          <a:xfrm>
-            <a:off x="822960" y="4279392"/>
-            <a:ext cx="457200" cy="457200"/>
-          </a:xfrm>
-          <a:prstGeom prst="rect">
-            <a:avLst/>
-          </a:prstGeom>
-          <a:noFill/>
-          <a:ln/>
-        </p:spPr>
-        <p:txBody>
-          <a:bodyPr wrap="square" rtlCol="0" anchor="ctr"/>
-          <a:lstStyle/>
-          <a:p>
-            <a:pPr marL="0" indent="0" algn="ctr">
-              <a:buNone/>
-            </a:pPr>
-            <a:r>
-              <a:rPr lang="en-US" sz="1600" b="1" dirty="0">
-                <a:solidFill>
-                  <a:srgbClr val="1C7293"/>
-                </a:solidFill>
-                <a:latin typeface="Cambria" pitchFamily="34" charset="0"/>
-                <a:ea typeface="Cambria" pitchFamily="34" charset="-122"/>
-                <a:cs typeface="Cambria" pitchFamily="34" charset="-120"/>
-              </a:rPr>
-              <a:t>3</a:t>
-            </a:r>
-            <a:endParaRPr lang="en-US" sz="1600" dirty="0"/>
-          </a:p>
-        </p:txBody>
-      </p:sp>
-      <p:sp>
-        <p:nvSpPr>
-          <p:cNvPr id="17" name="Text 15"/>
-          <p:cNvSpPr/>
-          <p:nvPr/>
-        </p:nvSpPr>
-        <p:spPr>
-          <a:xfrm>
-            <a:off x="1463040" y="4297680"/>
-            <a:ext cx="4206240" cy="411480"/>
-          </a:xfrm>
-          <a:prstGeom prst="rect">
-            <a:avLst/>
-          </a:prstGeom>
-          <a:noFill/>
-          <a:ln/>
-        </p:spPr>
-        <p:txBody>
-          <a:bodyPr wrap="square" rtlCol="0" anchor="ctr"/>
-          <a:lstStyle/>
-          <a:p>
-            <a:pPr marL="0" indent="0">
-              <a:buNone/>
-            </a:pPr>
-            <a:r>
-              <a:rPr lang="en-US" sz="1500" b="1" dirty="0">
-                <a:solidFill>
-                  <a:srgbClr val="20242B"/>
-                </a:solidFill>
-                <a:latin typeface="Calibri" pitchFamily="34" charset="0"/>
-                <a:ea typeface="Calibri" pitchFamily="34" charset="-122"/>
-                <a:cs typeface="Calibri" pitchFamily="34" charset="-120"/>
-              </a:rPr>
-              <a:t>Plotting tools</a:t>
-            </a:r>
-            <a:endParaRPr lang="en-US" sz="1500" dirty="0"/>
-          </a:p>
-        </p:txBody>
-      </p:sp>
-      <p:sp>
-        <p:nvSpPr>
-          <p:cNvPr id="18" name="Text 16"/>
-          <p:cNvSpPr/>
-          <p:nvPr/>
-        </p:nvSpPr>
-        <p:spPr>
-          <a:xfrm>
-            <a:off x="868680" y="4919472"/>
-            <a:ext cx="4800600" cy="868680"/>
-          </a:xfrm>
-          <a:prstGeom prst="rect">
-            <a:avLst/>
-          </a:prstGeom>
-          <a:noFill/>
-          <a:ln/>
-        </p:spPr>
-        <p:txBody>
-          <a:bodyPr wrap="square" rtlCol="0" anchor="ctr"/>
-          <a:lstStyle/>
-          <a:p>
-            <a:pPr marL="0" indent="0">
-              <a:lnSpc>
-                <a:spcPct val="120000"/>
-              </a:lnSpc>
-              <a:buNone/>
-            </a:pPr>
-            <a:r>
-              <a:rPr lang="en-US" sz="1150" dirty="0">
-                <a:solidFill>
-                  <a:srgbClr val="6E7580"/>
-                </a:solidFill>
-                <a:latin typeface="Calibri" pitchFamily="34" charset="0"/>
-                <a:ea typeface="Calibri" pitchFamily="34" charset="-122"/>
-                <a:cs typeface="Calibri" pitchFamily="34" charset="-120"/>
-              </a:rPr>
-              <a:t>A shared plotting toolchain (HTML/D3, pyqtgraph, matplotlib backends) visualises monitor output from both packages.</a:t>
-            </a:r>
-            <a:endParaRPr lang="en-US" sz="1150" dirty="0"/>
-          </a:p>
-        </p:txBody>
-      </p:sp>
-      <p:sp>
-        <p:nvSpPr>
-          <p:cNvPr id="19" name="Shape 17"/>
-          <p:cNvSpPr/>
-          <p:nvPr/>
-        </p:nvSpPr>
-        <p:spPr>
-          <a:xfrm>
-            <a:off x="6217920" y="4023360"/>
-            <a:ext cx="5394960" cy="1965960"/>
-          </a:xfrm>
-          <a:prstGeom prst="roundRect">
-            <a:avLst>
-              <a:gd name="adj" fmla="val 4186"/>
-            </a:avLst>
-          </a:prstGeom>
-          <a:solidFill>
-            <a:srgbClr val="F7F8FA"/>
-          </a:solidFill>
-          <a:ln/>
-        </p:spPr>
-        <p:txBody>
-          <a:bodyPr/>
-          <a:lstStyle/>
-          <a:p>
-            <a:endParaRPr lang="en-DK"/>
-          </a:p>
-        </p:txBody>
-      </p:sp>
-      <p:sp>
-        <p:nvSpPr>
-          <p:cNvPr id="20" name="Shape 18"/>
-          <p:cNvSpPr/>
-          <p:nvPr/>
-        </p:nvSpPr>
-        <p:spPr>
-          <a:xfrm>
-            <a:off x="6492240" y="4279392"/>
-            <a:ext cx="457200" cy="457200"/>
-          </a:xfrm>
-          <a:prstGeom prst="ellipse">
-            <a:avLst/>
-          </a:prstGeom>
-          <a:solidFill>
-            <a:srgbClr val="FBEBDA"/>
-          </a:solidFill>
-          <a:ln/>
-        </p:spPr>
-        <p:txBody>
-          <a:bodyPr/>
-          <a:lstStyle/>
-          <a:p>
-            <a:endParaRPr lang="en-DK"/>
-          </a:p>
-        </p:txBody>
-      </p:sp>
-      <p:sp>
-        <p:nvSpPr>
-          <p:cNvPr id="21" name="Text 19"/>
-          <p:cNvSpPr/>
-          <p:nvPr/>
-        </p:nvSpPr>
-        <p:spPr>
-          <a:xfrm>
-            <a:off x="6492240" y="4279392"/>
-            <a:ext cx="457200" cy="457200"/>
-          </a:xfrm>
-          <a:prstGeom prst="rect">
-            <a:avLst/>
-          </a:prstGeom>
-          <a:noFill/>
-          <a:ln/>
-        </p:spPr>
-        <p:txBody>
-          <a:bodyPr wrap="square" rtlCol="0" anchor="ctr"/>
-          <a:lstStyle/>
-          <a:p>
-            <a:pPr marL="0" indent="0" algn="ctr">
-              <a:buNone/>
-            </a:pPr>
-            <a:r>
-              <a:rPr lang="en-US" sz="1600" b="1" dirty="0">
-                <a:solidFill>
-                  <a:srgbClr val="D97A2B"/>
-                </a:solidFill>
-                <a:latin typeface="Cambria" pitchFamily="34" charset="0"/>
-                <a:ea typeface="Cambria" pitchFamily="34" charset="-122"/>
-                <a:cs typeface="Cambria" pitchFamily="34" charset="-120"/>
-              </a:rPr>
-              <a:t>4</a:t>
-            </a:r>
-            <a:endParaRPr lang="en-US" sz="1600" dirty="0"/>
-          </a:p>
-        </p:txBody>
-      </p:sp>
-      <p:sp>
-        <p:nvSpPr>
-          <p:cNvPr id="22" name="Text 20"/>
-          <p:cNvSpPr/>
-          <p:nvPr/>
-        </p:nvSpPr>
-        <p:spPr>
-          <a:xfrm>
-            <a:off x="7132320" y="4297680"/>
-            <a:ext cx="4206240" cy="411480"/>
-          </a:xfrm>
-          <a:prstGeom prst="rect">
-            <a:avLst/>
-          </a:prstGeom>
-          <a:noFill/>
-          <a:ln/>
-        </p:spPr>
-        <p:txBody>
-          <a:bodyPr wrap="square" rtlCol="0" anchor="ctr"/>
-          <a:lstStyle/>
-          <a:p>
-            <a:pPr marL="0" indent="0">
-              <a:buNone/>
-            </a:pPr>
-            <a:r>
-              <a:rPr lang="en-US" sz="1500" b="1" dirty="0">
-                <a:solidFill>
-                  <a:srgbClr val="20242B"/>
-                </a:solidFill>
-                <a:latin typeface="Calibri" pitchFamily="34" charset="0"/>
-                <a:ea typeface="Calibri" pitchFamily="34" charset="-122"/>
-                <a:cs typeface="Calibri" pitchFamily="34" charset="-120"/>
-              </a:rPr>
-              <a:t>Packaging</a:t>
-            </a:r>
-            <a:endParaRPr lang="en-US" sz="1500" dirty="0"/>
-          </a:p>
-        </p:txBody>
-      </p:sp>
-      <p:sp>
-        <p:nvSpPr>
-          <p:cNvPr id="23" name="Text 21"/>
-          <p:cNvSpPr/>
-          <p:nvPr/>
-        </p:nvSpPr>
-        <p:spPr>
-          <a:xfrm>
-            <a:off x="6537960" y="4919472"/>
-            <a:ext cx="4800600" cy="868680"/>
-          </a:xfrm>
-          <a:prstGeom prst="rect">
-            <a:avLst/>
-          </a:prstGeom>
-          <a:noFill/>
-          <a:ln/>
-        </p:spPr>
-        <p:txBody>
-          <a:bodyPr wrap="square" rtlCol="0" anchor="ctr"/>
-          <a:lstStyle/>
-          <a:p>
-            <a:pPr marL="0" indent="0">
-              <a:lnSpc>
-                <a:spcPct val="120000"/>
-              </a:lnSpc>
-              <a:buNone/>
-            </a:pPr>
-            <a:r>
-              <a:rPr lang="en-US" sz="1150" dirty="0">
-                <a:solidFill>
-                  <a:srgbClr val="6E7580"/>
-                </a:solidFill>
-                <a:latin typeface="Calibri" pitchFamily="34" charset="0"/>
-                <a:ea typeface="Calibri" pitchFamily="34" charset="-122"/>
-                <a:cs typeface="Calibri" pitchFamily="34" charset="-120"/>
-              </a:rPr>
-              <a:t>Conda-forge distributions and cross-platform installers keep both codes easy to install on Linux, macOS and Windows.</a:t>
-            </a:r>
-            <a:endParaRPr lang="en-US" sz="1150" dirty="0"/>
           </a:p>
         </p:txBody>
       </p:sp>
@@ -9021,6 +9705,99 @@
           </a:prstGeom>
         </p:spPr>
       </p:pic>
+      <p:grpSp>
+        <p:nvGrpSpPr>
+          <p:cNvPr id="28" name="Group">
+            <a:extLst>
+              <a:ext uri="{FF2B5EF4-FFF2-40B4-BE49-F238E27FC236}">
+                <a16:creationId xmlns:a16="http://schemas.microsoft.com/office/drawing/2014/main" id="{AF13E511-2C9F-6FB0-6033-278FD97BE5ED}"/>
+              </a:ext>
+            </a:extLst>
+          </p:cNvPr>
+          <p:cNvGrpSpPr>
+            <a:grpSpLocks noChangeAspect="1"/>
+          </p:cNvGrpSpPr>
+          <p:nvPr/>
+        </p:nvGrpSpPr>
+        <p:grpSpPr>
+          <a:xfrm>
+            <a:off x="908461" y="1124838"/>
+            <a:ext cx="10375077" cy="5508631"/>
+            <a:chOff x="0" y="0"/>
+            <a:chExt cx="16261443" cy="8633987"/>
+          </a:xfrm>
+        </p:grpSpPr>
+        <p:pic>
+          <p:nvPicPr>
+            <p:cNvPr id="29" name="Screenshot 2023-05-18 at 10.36.19.png" descr="Screenshot 2023-05-18 at 10.36.19.png">
+              <a:extLst>
+                <a:ext uri="{FF2B5EF4-FFF2-40B4-BE49-F238E27FC236}">
+                  <a16:creationId xmlns:a16="http://schemas.microsoft.com/office/drawing/2014/main" id="{7763D29B-9FC0-1848-EBD2-D1852CD8E8F8}"/>
+                </a:ext>
+              </a:extLst>
+            </p:cNvPr>
+            <p:cNvPicPr>
+              <a:picLocks noChangeAspect="1"/>
+            </p:cNvPicPr>
+            <p:nvPr/>
+          </p:nvPicPr>
+          <p:blipFill>
+            <a:blip r:embed="rId5"/>
+            <a:stretch>
+              <a:fillRect/>
+            </a:stretch>
+          </p:blipFill>
+          <p:spPr>
+            <a:xfrm>
+              <a:off x="0" y="0"/>
+              <a:ext cx="8575015" cy="8389252"/>
+            </a:xfrm>
+            <a:prstGeom prst="rect">
+              <a:avLst/>
+            </a:prstGeom>
+            <a:ln w="12700" cap="flat">
+              <a:noFill/>
+              <a:miter lim="400000"/>
+            </a:ln>
+            <a:effectLst/>
+          </p:spPr>
+        </p:pic>
+        <p:pic>
+          <p:nvPicPr>
+            <p:cNvPr id="30" name="Group" descr="Group">
+              <a:extLst>
+                <a:ext uri="{FF2B5EF4-FFF2-40B4-BE49-F238E27FC236}">
+                  <a16:creationId xmlns:a16="http://schemas.microsoft.com/office/drawing/2014/main" id="{8E822AA8-BEA7-B9EA-1CA0-5116E408F908}"/>
+                </a:ext>
+              </a:extLst>
+            </p:cNvPr>
+            <p:cNvPicPr>
+              <a:picLocks noChangeAspect="1"/>
+            </p:cNvPicPr>
+            <p:nvPr/>
+          </p:nvPicPr>
+          <p:blipFill>
+            <a:blip r:embed="rId6"/>
+            <a:stretch>
+              <a:fillRect/>
+            </a:stretch>
+          </p:blipFill>
+          <p:spPr>
+            <a:xfrm>
+              <a:off x="8260438" y="806310"/>
+              <a:ext cx="8001006" cy="7827678"/>
+            </a:xfrm>
+            <a:prstGeom prst="rect">
+              <a:avLst/>
+            </a:prstGeom>
+            <a:ln w="12700" cap="flat">
+              <a:noFill/>
+              <a:miter lim="400000"/>
+            </a:ln>
+            <a:effectLst/>
+          </p:spPr>
+        </p:pic>
+      </p:grpSp>
     </p:spTree>
     <p:extLst>
       <p:ext uri="{BB962C8B-B14F-4D97-AF65-F5344CB8AC3E}">
@@ -9034,7 +9811,7 @@
 </p:sld>
 </file>
 
-<file path=ppt/slides/slide16.xml><?xml version="1.0" encoding="utf-8"?>
+<file path=ppt/slides/slide17.xml><?xml version="1.0" encoding="utf-8"?>
 <p:sld xmlns:a="http://schemas.openxmlformats.org/drawingml/2006/main" xmlns:r="http://schemas.openxmlformats.org/officeDocument/2006/relationships" xmlns:p="http://schemas.openxmlformats.org/presentationml/2006/main">
   <p:cSld name="Slide 15">
     <p:bg>
@@ -10042,6 +10819,41 @@
           </a:prstGeom>
         </p:spPr>
       </p:pic>
+      <p:sp>
+        <p:nvSpPr>
+          <p:cNvPr id="28" name="TextBox 27">
+            <a:extLst>
+              <a:ext uri="{FF2B5EF4-FFF2-40B4-BE49-F238E27FC236}">
+                <a16:creationId xmlns:a16="http://schemas.microsoft.com/office/drawing/2014/main" id="{8778A11B-01A1-5E6D-28CB-9B18DF4F40B6}"/>
+              </a:ext>
+            </a:extLst>
+          </p:cNvPr>
+          <p:cNvSpPr txBox="1"/>
+          <p:nvPr/>
+        </p:nvSpPr>
+        <p:spPr>
+          <a:xfrm>
+            <a:off x="3177540" y="5852160"/>
+            <a:ext cx="5651589" cy="369332"/>
+          </a:xfrm>
+          <a:prstGeom prst="rect">
+            <a:avLst/>
+          </a:prstGeom>
+          <a:noFill/>
+        </p:spPr>
+        <p:txBody>
+          <a:bodyPr wrap="square" rtlCol="0">
+            <a:spAutoFit/>
+          </a:bodyPr>
+          <a:lstStyle/>
+          <a:p>
+            <a:r>
+              <a:rPr lang="en-DK" dirty="0"/>
+              <a:t>micromamba env create – n panraid mcstas mcxtrace -y</a:t>
+            </a:r>
+          </a:p>
+        </p:txBody>
+      </p:sp>
     </p:spTree>
     <p:extLst>
       <p:ext uri="{BB962C8B-B14F-4D97-AF65-F5344CB8AC3E}">
@@ -10055,7 +10867,7 @@
 </p:sld>
 </file>
 
-<file path=ppt/slides/slide17.xml><?xml version="1.0" encoding="utf-8"?>
+<file path=ppt/slides/slide18.xml><?xml version="1.0" encoding="utf-8"?>
 <p:sld xmlns:a="http://schemas.openxmlformats.org/drawingml/2006/main" xmlns:r="http://schemas.openxmlformats.org/officeDocument/2006/relationships" xmlns:p="http://schemas.openxmlformats.org/presentationml/2006/main">
   <p:cSld name="Slide 16">
     <p:bg>
@@ -10088,7 +10900,7 @@
         </p:nvSpPr>
         <p:spPr>
           <a:xfrm>
-            <a:off x="9418320" y="-1463040"/>
+            <a:off x="9410193" y="-1457675"/>
             <a:ext cx="4754880" cy="4754880"/>
           </a:xfrm>
           <a:prstGeom prst="ellipse">
@@ -10665,6 +11477,225 @@
           </a:prstGeom>
         </p:spPr>
       </p:pic>
+      <p:sp>
+        <p:nvSpPr>
+          <p:cNvPr id="18" name="LogoCard">
+            <a:extLst>
+              <a:ext uri="{FF2B5EF4-FFF2-40B4-BE49-F238E27FC236}">
+                <a16:creationId xmlns:a16="http://schemas.microsoft.com/office/drawing/2014/main" id="{43FCA9E4-FE53-9770-866A-69BD74D27A0B}"/>
+              </a:ext>
+            </a:extLst>
+          </p:cNvPr>
+          <p:cNvSpPr/>
+          <p:nvPr/>
+        </p:nvSpPr>
+        <p:spPr>
+          <a:xfrm>
+            <a:off x="7375855" y="2105660"/>
+            <a:ext cx="3810000" cy="1498600"/>
+          </a:xfrm>
+          <a:prstGeom prst="roundRect">
+            <a:avLst/>
+          </a:prstGeom>
+          <a:solidFill>
+            <a:srgbClr val="FFFFFF"/>
+          </a:solidFill>
+          <a:ln w="12700" cap="flat" cmpd="sng" algn="ctr">
+            <a:noFill/>
+            <a:prstDash val="solid"/>
+            <a:miter lim="800000"/>
+          </a:ln>
+        </p:spPr>
+        <p:style>
+          <a:lnRef idx="2">
+            <a:schemeClr val="accent1">
+              <a:shade val="15000"/>
+            </a:schemeClr>
+          </a:lnRef>
+          <a:fillRef idx="1">
+            <a:schemeClr val="accent1"/>
+          </a:fillRef>
+          <a:effectRef idx="0">
+            <a:schemeClr val="accent1"/>
+          </a:effectRef>
+          <a:fontRef idx="minor">
+            <a:schemeClr val="lt1"/>
+          </a:fontRef>
+        </p:style>
+        <p:txBody>
+          <a:bodyPr vertOverflow="clip" horzOverflow="clip" rtlCol="0" anchor="t"/>
+          <a:lstStyle/>
+          <a:p>
+            <a:pPr algn="l"/>
+            <a:endParaRPr lang="en-DK"/>
+          </a:p>
+        </p:txBody>
+      </p:sp>
+      <p:grpSp>
+        <p:nvGrpSpPr>
+          <p:cNvPr id="19" name="Group 18">
+            <a:extLst>
+              <a:ext uri="{FF2B5EF4-FFF2-40B4-BE49-F238E27FC236}">
+                <a16:creationId xmlns:a16="http://schemas.microsoft.com/office/drawing/2014/main" id="{1AFF1637-3776-19F4-C2BF-C8A792464BAB}"/>
+              </a:ext>
+            </a:extLst>
+          </p:cNvPr>
+          <p:cNvGrpSpPr>
+            <a:grpSpLocks noChangeAspect="1"/>
+          </p:cNvGrpSpPr>
+          <p:nvPr/>
+        </p:nvGrpSpPr>
+        <p:grpSpPr>
+          <a:xfrm>
+            <a:off x="7882485" y="2194129"/>
+            <a:ext cx="2796739" cy="1321661"/>
+            <a:chOff x="8424483" y="116876"/>
+            <a:chExt cx="1591152" cy="751934"/>
+          </a:xfrm>
+        </p:grpSpPr>
+        <p:grpSp>
+          <p:nvGrpSpPr>
+            <p:cNvPr id="20" name="Group 19">
+              <a:extLst>
+                <a:ext uri="{FF2B5EF4-FFF2-40B4-BE49-F238E27FC236}">
+                  <a16:creationId xmlns:a16="http://schemas.microsoft.com/office/drawing/2014/main" id="{42E9DF56-F934-B503-5BC1-AB1E0626EF87}"/>
+                </a:ext>
+              </a:extLst>
+            </p:cNvPr>
+            <p:cNvGrpSpPr/>
+            <p:nvPr/>
+          </p:nvGrpSpPr>
+          <p:grpSpPr>
+            <a:xfrm>
+              <a:off x="9225045" y="116876"/>
+              <a:ext cx="790590" cy="715989"/>
+              <a:chOff x="9198715" y="165515"/>
+              <a:chExt cx="790590" cy="715989"/>
+            </a:xfrm>
+          </p:grpSpPr>
+          <p:pic>
+            <p:nvPicPr>
+              <p:cNvPr id="22" name="Picture 21">
+                <a:extLst>
+                  <a:ext uri="{FF2B5EF4-FFF2-40B4-BE49-F238E27FC236}">
+                    <a16:creationId xmlns:a16="http://schemas.microsoft.com/office/drawing/2014/main" id="{FCE6B836-1674-13D5-AEC8-35C69BC1EB8F}"/>
+                  </a:ext>
+                </a:extLst>
+              </p:cNvPr>
+              <p:cNvPicPr>
+                <a:picLocks noChangeAspect="1"/>
+              </p:cNvPicPr>
+              <p:nvPr/>
+            </p:nvPicPr>
+            <p:blipFill>
+              <a:blip r:embed="rId5"/>
+              <a:srcRect l="48140"/>
+              <a:stretch>
+                <a:fillRect/>
+              </a:stretch>
+            </p:blipFill>
+            <p:spPr>
+              <a:xfrm>
+                <a:off x="9226947" y="165515"/>
+                <a:ext cx="736600" cy="441669"/>
+              </a:xfrm>
+              <a:prstGeom prst="rect">
+                <a:avLst/>
+              </a:prstGeom>
+            </p:spPr>
+          </p:pic>
+          <p:pic>
+            <p:nvPicPr>
+              <p:cNvPr id="23" name="Picture 22" descr="Synchrotron SOLEIL">
+                <a:extLst>
+                  <a:ext uri="{FF2B5EF4-FFF2-40B4-BE49-F238E27FC236}">
+                    <a16:creationId xmlns:a16="http://schemas.microsoft.com/office/drawing/2014/main" id="{3D803075-2756-B905-7457-984389512468}"/>
+                  </a:ext>
+                </a:extLst>
+              </p:cNvPr>
+              <p:cNvPicPr>
+                <a:picLocks noChangeAspect="1"/>
+              </p:cNvPicPr>
+              <p:nvPr/>
+            </p:nvPicPr>
+            <p:blipFill>
+              <a:blip r:embed="rId6"/>
+              <a:stretch>
+                <a:fillRect/>
+              </a:stretch>
+            </p:blipFill>
+            <p:spPr>
+              <a:xfrm>
+                <a:off x="9198715" y="580162"/>
+                <a:ext cx="548117" cy="264791"/>
+              </a:xfrm>
+              <a:prstGeom prst="rect">
+                <a:avLst/>
+              </a:prstGeom>
+            </p:spPr>
+          </p:pic>
+          <p:pic>
+            <p:nvPicPr>
+              <p:cNvPr id="24" name="Picture 23" descr="DTU Physics">
+                <a:extLst>
+                  <a:ext uri="{FF2B5EF4-FFF2-40B4-BE49-F238E27FC236}">
+                    <a16:creationId xmlns:a16="http://schemas.microsoft.com/office/drawing/2014/main" id="{2501FE40-6F55-3E26-4852-118F58348A5D}"/>
+                  </a:ext>
+                </a:extLst>
+              </p:cNvPr>
+              <p:cNvPicPr>
+                <a:picLocks noChangeAspect="1"/>
+              </p:cNvPicPr>
+              <p:nvPr/>
+            </p:nvPicPr>
+            <p:blipFill>
+              <a:blip r:embed="rId7"/>
+              <a:stretch>
+                <a:fillRect/>
+              </a:stretch>
+            </p:blipFill>
+            <p:spPr>
+              <a:xfrm>
+                <a:off x="9787903" y="584997"/>
+                <a:ext cx="201402" cy="296507"/>
+              </a:xfrm>
+              <a:prstGeom prst="rect">
+                <a:avLst/>
+              </a:prstGeom>
+            </p:spPr>
+          </p:pic>
+        </p:grpSp>
+        <p:pic>
+          <p:nvPicPr>
+            <p:cNvPr id="21" name="Picture 20">
+              <a:extLst>
+                <a:ext uri="{FF2B5EF4-FFF2-40B4-BE49-F238E27FC236}">
+                  <a16:creationId xmlns:a16="http://schemas.microsoft.com/office/drawing/2014/main" id="{4FD7261C-4B8B-3050-5C1C-55C88AC9D454}"/>
+                </a:ext>
+              </a:extLst>
+            </p:cNvPr>
+            <p:cNvPicPr>
+              <a:picLocks noChangeAspect="1"/>
+            </p:cNvPicPr>
+            <p:nvPr/>
+          </p:nvPicPr>
+          <p:blipFill>
+            <a:blip r:embed="rId8"/>
+            <a:stretch>
+              <a:fillRect/>
+            </a:stretch>
+          </p:blipFill>
+          <p:spPr>
+            <a:xfrm>
+              <a:off x="8424483" y="119510"/>
+              <a:ext cx="736600" cy="749300"/>
+            </a:xfrm>
+            <a:prstGeom prst="rect">
+              <a:avLst/>
+            </a:prstGeom>
+          </p:spPr>
+        </p:pic>
+      </p:grpSp>
     </p:spTree>
     <p:extLst>
       <p:ext uri="{BB962C8B-B14F-4D97-AF65-F5344CB8AC3E}">
@@ -13128,7 +14159,7 @@
         </p:nvSpPr>
         <p:spPr>
           <a:xfrm>
-            <a:off x="548640" y="5806440"/>
+            <a:off x="372476" y="1778638"/>
             <a:ext cx="11064240" cy="594360"/>
           </a:xfrm>
           <a:prstGeom prst="roundRect">
@@ -13162,7 +14193,7 @@
         </p:nvSpPr>
         <p:spPr>
           <a:xfrm>
-            <a:off x="777240" y="5806440"/>
+            <a:off x="601076" y="1778638"/>
             <a:ext cx="10607040" cy="594360"/>
           </a:xfrm>
           <a:prstGeom prst="rect">
@@ -13349,6 +14380,371 @@
           </a:prstGeom>
         </p:spPr>
       </p:pic>
+      <p:pic>
+        <p:nvPicPr>
+          <p:cNvPr id="28" name="Picture 27">
+            <a:extLst>
+              <a:ext uri="{FF2B5EF4-FFF2-40B4-BE49-F238E27FC236}">
+                <a16:creationId xmlns:a16="http://schemas.microsoft.com/office/drawing/2014/main" id="{0BAE991F-EF6F-C843-3CBC-4A58921A55E8}"/>
+              </a:ext>
+            </a:extLst>
+          </p:cNvPr>
+          <p:cNvPicPr>
+            <a:picLocks noChangeAspect="1"/>
+          </p:cNvPicPr>
+          <p:nvPr/>
+        </p:nvPicPr>
+        <p:blipFill>
+          <a:blip r:embed="rId5"/>
+          <a:stretch>
+            <a:fillRect/>
+          </a:stretch>
+        </p:blipFill>
+        <p:spPr>
+          <a:xfrm>
+            <a:off x="1747519" y="5157216"/>
+            <a:ext cx="1270001" cy="858720"/>
+          </a:xfrm>
+          <a:prstGeom prst="rect">
+            <a:avLst/>
+          </a:prstGeom>
+        </p:spPr>
+      </p:pic>
+      <p:grpSp>
+        <p:nvGrpSpPr>
+          <p:cNvPr id="34" name="Group 33">
+            <a:extLst>
+              <a:ext uri="{FF2B5EF4-FFF2-40B4-BE49-F238E27FC236}">
+                <a16:creationId xmlns:a16="http://schemas.microsoft.com/office/drawing/2014/main" id="{8078D3C4-BCBE-1092-28E6-E5848D027363}"/>
+              </a:ext>
+            </a:extLst>
+          </p:cNvPr>
+          <p:cNvGrpSpPr/>
+          <p:nvPr/>
+        </p:nvGrpSpPr>
+        <p:grpSpPr>
+          <a:xfrm>
+            <a:off x="8424483" y="116876"/>
+            <a:ext cx="1591152" cy="751934"/>
+            <a:chOff x="8424483" y="116876"/>
+            <a:chExt cx="1591152" cy="751934"/>
+          </a:xfrm>
+        </p:grpSpPr>
+        <p:grpSp>
+          <p:nvGrpSpPr>
+            <p:cNvPr id="33" name="Group 32">
+              <a:extLst>
+                <a:ext uri="{FF2B5EF4-FFF2-40B4-BE49-F238E27FC236}">
+                  <a16:creationId xmlns:a16="http://schemas.microsoft.com/office/drawing/2014/main" id="{6D14071F-E8AD-203A-290B-81D2D367195D}"/>
+                </a:ext>
+              </a:extLst>
+            </p:cNvPr>
+            <p:cNvGrpSpPr/>
+            <p:nvPr/>
+          </p:nvGrpSpPr>
+          <p:grpSpPr>
+            <a:xfrm>
+              <a:off x="9225045" y="116876"/>
+              <a:ext cx="790590" cy="715989"/>
+              <a:chOff x="9198715" y="165515"/>
+              <a:chExt cx="790590" cy="715989"/>
+            </a:xfrm>
+          </p:grpSpPr>
+          <p:pic>
+            <p:nvPicPr>
+              <p:cNvPr id="29" name="Picture 28">
+                <a:extLst>
+                  <a:ext uri="{FF2B5EF4-FFF2-40B4-BE49-F238E27FC236}">
+                    <a16:creationId xmlns:a16="http://schemas.microsoft.com/office/drawing/2014/main" id="{834E52CA-CC1C-7859-C38D-67CC9CFF997C}"/>
+                  </a:ext>
+                </a:extLst>
+              </p:cNvPr>
+              <p:cNvPicPr>
+                <a:picLocks noChangeAspect="1"/>
+              </p:cNvPicPr>
+              <p:nvPr/>
+            </p:nvPicPr>
+            <p:blipFill>
+              <a:blip r:embed="rId6"/>
+              <a:srcRect l="48140"/>
+              <a:stretch>
+                <a:fillRect/>
+              </a:stretch>
+            </p:blipFill>
+            <p:spPr>
+              <a:xfrm>
+                <a:off x="9226947" y="165515"/>
+                <a:ext cx="736600" cy="441669"/>
+              </a:xfrm>
+              <a:prstGeom prst="rect">
+                <a:avLst/>
+              </a:prstGeom>
+            </p:spPr>
+          </p:pic>
+          <p:pic>
+            <p:nvPicPr>
+              <p:cNvPr id="30" name="Picture 29" descr="Synchrotron SOLEIL">
+                <a:extLst>
+                  <a:ext uri="{FF2B5EF4-FFF2-40B4-BE49-F238E27FC236}">
+                    <a16:creationId xmlns:a16="http://schemas.microsoft.com/office/drawing/2014/main" id="{0BED68E3-56D0-D144-FB9D-2766AA872803}"/>
+                  </a:ext>
+                </a:extLst>
+              </p:cNvPr>
+              <p:cNvPicPr>
+                <a:picLocks noChangeAspect="1"/>
+              </p:cNvPicPr>
+              <p:nvPr/>
+            </p:nvPicPr>
+            <p:blipFill>
+              <a:blip r:embed="rId7"/>
+              <a:stretch>
+                <a:fillRect/>
+              </a:stretch>
+            </p:blipFill>
+            <p:spPr>
+              <a:xfrm>
+                <a:off x="9198715" y="580162"/>
+                <a:ext cx="548117" cy="264791"/>
+              </a:xfrm>
+              <a:prstGeom prst="rect">
+                <a:avLst/>
+              </a:prstGeom>
+            </p:spPr>
+          </p:pic>
+          <p:pic>
+            <p:nvPicPr>
+              <p:cNvPr id="31" name="Picture 30" descr="DTU Physics">
+                <a:extLst>
+                  <a:ext uri="{FF2B5EF4-FFF2-40B4-BE49-F238E27FC236}">
+                    <a16:creationId xmlns:a16="http://schemas.microsoft.com/office/drawing/2014/main" id="{A85B7DBF-0CA9-C174-1944-15DDF4E77986}"/>
+                  </a:ext>
+                </a:extLst>
+              </p:cNvPr>
+              <p:cNvPicPr>
+                <a:picLocks noChangeAspect="1"/>
+              </p:cNvPicPr>
+              <p:nvPr/>
+            </p:nvPicPr>
+            <p:blipFill>
+              <a:blip r:embed="rId8"/>
+              <a:stretch>
+                <a:fillRect/>
+              </a:stretch>
+            </p:blipFill>
+            <p:spPr>
+              <a:xfrm>
+                <a:off x="9787903" y="584997"/>
+                <a:ext cx="201402" cy="296507"/>
+              </a:xfrm>
+              <a:prstGeom prst="rect">
+                <a:avLst/>
+              </a:prstGeom>
+            </p:spPr>
+          </p:pic>
+        </p:grpSp>
+        <p:pic>
+          <p:nvPicPr>
+            <p:cNvPr id="32" name="Picture 31">
+              <a:extLst>
+                <a:ext uri="{FF2B5EF4-FFF2-40B4-BE49-F238E27FC236}">
+                  <a16:creationId xmlns:a16="http://schemas.microsoft.com/office/drawing/2014/main" id="{2AF63781-724E-C5AF-1E5B-58A44F1098DC}"/>
+                </a:ext>
+              </a:extLst>
+            </p:cNvPr>
+            <p:cNvPicPr>
+              <a:picLocks noChangeAspect="1"/>
+            </p:cNvPicPr>
+            <p:nvPr/>
+          </p:nvPicPr>
+          <p:blipFill>
+            <a:blip r:embed="rId9"/>
+            <a:stretch>
+              <a:fillRect/>
+            </a:stretch>
+          </p:blipFill>
+          <p:spPr>
+            <a:xfrm>
+              <a:off x="8424483" y="119510"/>
+              <a:ext cx="736600" cy="749300"/>
+            </a:xfrm>
+            <a:prstGeom prst="rect">
+              <a:avLst/>
+            </a:prstGeom>
+          </p:spPr>
+        </p:pic>
+      </p:grpSp>
+      <p:pic>
+        <p:nvPicPr>
+          <p:cNvPr id="35" name="Picture 34">
+            <a:extLst>
+              <a:ext uri="{FF2B5EF4-FFF2-40B4-BE49-F238E27FC236}">
+                <a16:creationId xmlns:a16="http://schemas.microsoft.com/office/drawing/2014/main" id="{87C6BD29-A22B-BFA1-A46F-9BE9B88BB1AA}"/>
+              </a:ext>
+            </a:extLst>
+          </p:cNvPr>
+          <p:cNvPicPr>
+            <a:picLocks noChangeAspect="1"/>
+          </p:cNvPicPr>
+          <p:nvPr/>
+        </p:nvPicPr>
+        <p:blipFill>
+          <a:blip r:embed="rId10"/>
+          <a:stretch>
+            <a:fillRect/>
+          </a:stretch>
+        </p:blipFill>
+        <p:spPr>
+          <a:xfrm>
+            <a:off x="3274408" y="5328203"/>
+            <a:ext cx="2029519" cy="1298440"/>
+          </a:xfrm>
+          <a:prstGeom prst="rect">
+            <a:avLst/>
+          </a:prstGeom>
+        </p:spPr>
+      </p:pic>
+      <p:pic>
+        <p:nvPicPr>
+          <p:cNvPr id="37" name="Picture 36">
+            <a:extLst>
+              <a:ext uri="{FF2B5EF4-FFF2-40B4-BE49-F238E27FC236}">
+                <a16:creationId xmlns:a16="http://schemas.microsoft.com/office/drawing/2014/main" id="{F6B41B72-8D75-B23A-0F3C-395228A7EA5C}"/>
+              </a:ext>
+            </a:extLst>
+          </p:cNvPr>
+          <p:cNvPicPr>
+            <a:picLocks noChangeAspect="1"/>
+          </p:cNvPicPr>
+          <p:nvPr/>
+        </p:nvPicPr>
+        <p:blipFill>
+          <a:blip r:embed="rId11"/>
+          <a:stretch>
+            <a:fillRect/>
+          </a:stretch>
+        </p:blipFill>
+        <p:spPr>
+          <a:xfrm>
+            <a:off x="5753630" y="5353320"/>
+            <a:ext cx="2391619" cy="1280149"/>
+          </a:xfrm>
+          <a:prstGeom prst="rect">
+            <a:avLst/>
+          </a:prstGeom>
+        </p:spPr>
+      </p:pic>
+      <p:grpSp>
+        <p:nvGrpSpPr>
+          <p:cNvPr id="41" name="Group 40">
+            <a:extLst>
+              <a:ext uri="{FF2B5EF4-FFF2-40B4-BE49-F238E27FC236}">
+                <a16:creationId xmlns:a16="http://schemas.microsoft.com/office/drawing/2014/main" id="{6AD752E5-1752-9141-D8AC-C0FC18145FFD}"/>
+              </a:ext>
+            </a:extLst>
+          </p:cNvPr>
+          <p:cNvGrpSpPr/>
+          <p:nvPr/>
+        </p:nvGrpSpPr>
+        <p:grpSpPr>
+          <a:xfrm>
+            <a:off x="8366156" y="5248656"/>
+            <a:ext cx="790590" cy="715989"/>
+            <a:chOff x="9377445" y="269276"/>
+            <a:chExt cx="790590" cy="715989"/>
+          </a:xfrm>
+        </p:grpSpPr>
+        <p:pic>
+          <p:nvPicPr>
+            <p:cNvPr id="38" name="Picture 37">
+              <a:extLst>
+                <a:ext uri="{FF2B5EF4-FFF2-40B4-BE49-F238E27FC236}">
+                  <a16:creationId xmlns:a16="http://schemas.microsoft.com/office/drawing/2014/main" id="{3EF27FFB-0D0B-5A7C-FCCB-A618E441A2A9}"/>
+                </a:ext>
+              </a:extLst>
+            </p:cNvPr>
+            <p:cNvPicPr>
+              <a:picLocks noChangeAspect="1"/>
+            </p:cNvPicPr>
+            <p:nvPr/>
+          </p:nvPicPr>
+          <p:blipFill>
+            <a:blip r:embed="rId6"/>
+            <a:srcRect l="48140"/>
+            <a:stretch>
+              <a:fillRect/>
+            </a:stretch>
+          </p:blipFill>
+          <p:spPr>
+            <a:xfrm>
+              <a:off x="9405677" y="269276"/>
+              <a:ext cx="736600" cy="441669"/>
+            </a:xfrm>
+            <a:prstGeom prst="rect">
+              <a:avLst/>
+            </a:prstGeom>
+          </p:spPr>
+        </p:pic>
+        <p:pic>
+          <p:nvPicPr>
+            <p:cNvPr id="39" name="Picture 38" descr="Synchrotron SOLEIL">
+              <a:extLst>
+                <a:ext uri="{FF2B5EF4-FFF2-40B4-BE49-F238E27FC236}">
+                  <a16:creationId xmlns:a16="http://schemas.microsoft.com/office/drawing/2014/main" id="{D2D9A958-E24D-1D4D-72E2-6EFACF0B1EF0}"/>
+                </a:ext>
+              </a:extLst>
+            </p:cNvPr>
+            <p:cNvPicPr>
+              <a:picLocks noChangeAspect="1"/>
+            </p:cNvPicPr>
+            <p:nvPr/>
+          </p:nvPicPr>
+          <p:blipFill>
+            <a:blip r:embed="rId7"/>
+            <a:stretch>
+              <a:fillRect/>
+            </a:stretch>
+          </p:blipFill>
+          <p:spPr>
+            <a:xfrm>
+              <a:off x="9377445" y="683923"/>
+              <a:ext cx="548117" cy="264791"/>
+            </a:xfrm>
+            <a:prstGeom prst="rect">
+              <a:avLst/>
+            </a:prstGeom>
+          </p:spPr>
+        </p:pic>
+        <p:pic>
+          <p:nvPicPr>
+            <p:cNvPr id="40" name="Picture 39" descr="DTU Physics">
+              <a:extLst>
+                <a:ext uri="{FF2B5EF4-FFF2-40B4-BE49-F238E27FC236}">
+                  <a16:creationId xmlns:a16="http://schemas.microsoft.com/office/drawing/2014/main" id="{01FA497A-B984-7580-C8EA-88AE7376CE72}"/>
+                </a:ext>
+              </a:extLst>
+            </p:cNvPr>
+            <p:cNvPicPr>
+              <a:picLocks noChangeAspect="1"/>
+            </p:cNvPicPr>
+            <p:nvPr/>
+          </p:nvPicPr>
+          <p:blipFill>
+            <a:blip r:embed="rId8"/>
+            <a:stretch>
+              <a:fillRect/>
+            </a:stretch>
+          </p:blipFill>
+          <p:spPr>
+            <a:xfrm>
+              <a:off x="9966633" y="688758"/>
+              <a:ext cx="201402" cy="296507"/>
+            </a:xfrm>
+            <a:prstGeom prst="rect">
+              <a:avLst/>
+            </a:prstGeom>
+          </p:spPr>
+        </p:pic>
+      </p:grpSp>
     </p:spTree>
     <p:extLst>
       <p:ext uri="{BB962C8B-B14F-4D97-AF65-F5344CB8AC3E}">

</xml_diff>